<commit_message>
Swap primary/fallback Ollama models for latency; add smart bypass, semantic answer cache, OpenWebUI task detection
llama3.2:3b is now primary (~2x faster generation than qwen2.5:7b-instruct
on CPU-only hardware); qwen2.5:7b-instruct becomes the fallback. Updated
settings.py, .env.example, README, deployment docs, ADR-004, and the deck.

Also lands the two config-toggleable latency optimizations built this
session: a regex/cosine-similarity smart bypass for the Planner and
Evidence Validator (107.8s -> 58.3s), a Postgres+pgvector semantic answer
cache (50.6s -> 0.1s on repeat/paraphrased questions), and OpenWebUI
title-generation short-circuiting so its internal calls don't run the
full 5-agent pipeline. Fixes PHOENIX_WORKING_DIR so Phoenix trace history
actually persists across `make down`.
</commit_message>
<xml_diff>
--- a/doc/presentation/AegisRAG — Enterprise Agentic Document Intelligence Platform.pptx
+++ b/doc/presentation/AegisRAG — Enterprise Agentic Document Intelligence Platform.pptx
@@ -4,9 +4,6 @@
   <p:sldMasterIdLst>
     <p:sldMasterId id="2147483648" r:id="rId1"/>
   </p:sldMasterIdLst>
-  <p:notesMasterIdLst>
-    <p:notesMasterId r:id="rId16"/>
-  </p:notesMasterIdLst>
   <p:sldIdLst>
     <p:sldId id="256" r:id="rId2"/>
     <p:sldId id="257" r:id="rId3"/>
@@ -22,7 +19,11 @@
     <p:sldId id="267" r:id="rId13"/>
     <p:sldId id="268" r:id="rId14"/>
     <p:sldId id="269" r:id="rId15"/>
+    <p:sldId id="270" r:id="rId16"/>
   </p:sldIdLst>
+  <p:notesMasterIdLst>
+    <p:notesMasterId r:id="rId17"/>
+  </p:notesMasterIdLst>
   <p:sldSz cx="12192000" cy="6858000"/>
   <p:notesSz cx="6858000" cy="12192000"/>
   <p:defaultTextStyle>
@@ -117,11 +118,6 @@
       </a:defRPr>
     </a:lvl9pPr>
   </p:defaultTextStyle>
-  <p:extLst>
-    <p:ext uri="{EFAFB233-063F-42B5-8137-9DF3F51BA10A}">
-      <p15:sldGuideLst xmlns:p15="http://schemas.microsoft.com/office/powerpoint/2012/main"/>
-    </p:ext>
-  </p:extLst>
 </p:presentation>
 </file>
 
@@ -147,10 +143,234 @@
           <a:chExt cx="0" cy="0"/>
         </a:xfrm>
       </p:grpSpPr>
+      <p:sp>
+        <p:nvSpPr>
+          <p:cNvPr id="2" name="Header Placeholder 1"/>
+          <p:cNvSpPr>
+            <a:spLocks noGrp="1"/>
+          </p:cNvSpPr>
+          <p:nvPr>
+            <p:ph type="hdr" sz="quarter"/>
+          </p:nvPr>
+        </p:nvSpPr>
+        <p:spPr>
+          <a:xfrm>
+            <a:off x="0" y="0"/>
+            <a:ext cx="2971800" cy="458788"/>
+          </a:xfrm>
+          <a:prstGeom prst="rect">
+            <a:avLst/>
+          </a:prstGeom>
+        </p:spPr>
+        <p:txBody>
+          <a:bodyPr vert="horz" lIns="91440" tIns="45720" rIns="91440" bIns="45720" rtlCol="0"/>
+          <a:lstStyle>
+            <a:lvl1pPr algn="l">
+              <a:defRPr sz="1200"/>
+            </a:lvl1pPr>
+          </a:lstStyle>
+          <a:p>
+            <a:endParaRPr lang="en-US"/>
+          </a:p>
+        </p:txBody>
+      </p:sp>
+      <p:sp>
+        <p:nvSpPr>
+          <p:cNvPr id="3" name="Date Placeholder 2"/>
+          <p:cNvSpPr>
+            <a:spLocks noGrp="1"/>
+          </p:cNvSpPr>
+          <p:nvPr>
+            <p:ph type="dt" idx="1"/>
+          </p:nvPr>
+        </p:nvSpPr>
+        <p:spPr>
+          <a:xfrm>
+            <a:off x="3884613" y="0"/>
+            <a:ext cx="2971800" cy="458788"/>
+          </a:xfrm>
+          <a:prstGeom prst="rect">
+            <a:avLst/>
+          </a:prstGeom>
+        </p:spPr>
+        <p:txBody>
+          <a:bodyPr vert="horz" lIns="91440" tIns="45720" rIns="91440" bIns="45720" rtlCol="0"/>
+          <a:lstStyle>
+            <a:lvl1pPr algn="r">
+              <a:defRPr sz="1200"/>
+            </a:lvl1pPr>
+          </a:lstStyle>
+          <a:p>
+            <a:fld id="{5282F153-3F37-0F45-9E97-73ACFA13230C}" type="datetimeFigureOut">
+              <a:rPr lang="en-US"/>
+              <a:t>7/23/19</a:t>
+            </a:fld>
+            <a:endParaRPr lang="en-US"/>
+          </a:p>
+        </p:txBody>
+      </p:sp>
+      <p:sp>
+        <p:nvSpPr>
+          <p:cNvPr id="4" name="Slide Image Placeholder 3"/>
+          <p:cNvSpPr>
+            <a:spLocks noGrp="1" noRot="1" noChangeAspect="1"/>
+          </p:cNvSpPr>
+          <p:nvPr>
+            <p:ph type="sldImg" idx="2"/>
+          </p:nvPr>
+        </p:nvSpPr>
+        <p:spPr>
+          <a:xfrm>
+            <a:off x="685800" y="1143000"/>
+            <a:ext cx="5486400" cy="3086100"/>
+          </a:xfrm>
+          <a:prstGeom prst="rect">
+            <a:avLst/>
+          </a:prstGeom>
+          <a:noFill/>
+          <a:ln w="12700">
+            <a:solidFill>
+              <a:prstClr val="black"/>
+            </a:solidFill>
+          </a:ln>
+        </p:spPr>
+        <p:txBody>
+          <a:bodyPr vert="horz" lIns="91440" tIns="45720" rIns="91440" bIns="45720" rtlCol="0" anchor="ctr"/>
+          <a:lstStyle/>
+          <a:p>
+            <a:endParaRPr lang="en-US"/>
+          </a:p>
+        </p:txBody>
+      </p:sp>
+      <p:sp>
+        <p:nvSpPr>
+          <p:cNvPr id="5" name="Notes Placeholder 4"/>
+          <p:cNvSpPr>
+            <a:spLocks noGrp="1"/>
+          </p:cNvSpPr>
+          <p:nvPr>
+            <p:ph type="body" sz="quarter" idx="3"/>
+          </p:nvPr>
+        </p:nvSpPr>
+        <p:spPr>
+          <a:xfrm>
+            <a:off x="685800" y="4400550"/>
+            <a:ext cx="5486400" cy="3600450"/>
+          </a:xfrm>
+          <a:prstGeom prst="rect">
+            <a:avLst/>
+          </a:prstGeom>
+        </p:spPr>
+        <p:txBody>
+          <a:bodyPr vert="horz" lIns="91440" tIns="45720" rIns="91440" bIns="45720" rtlCol="0"/>
+          <a:lstStyle/>
+          <a:p>
+            <a:pPr lvl="0"/>
+            <a:r>
+              <a:rPr lang="en-US"/>
+              <a:t>Click to edit Master text styles</a:t>
+            </a:r>
+          </a:p>
+          <a:p>
+            <a:pPr lvl="1"/>
+            <a:r>
+              <a:rPr lang="en-US"/>
+              <a:t>Second level</a:t>
+            </a:r>
+          </a:p>
+          <a:p>
+            <a:pPr lvl="2"/>
+            <a:r>
+              <a:rPr lang="en-US"/>
+              <a:t>Third level</a:t>
+            </a:r>
+          </a:p>
+          <a:p>
+            <a:pPr lvl="3"/>
+            <a:r>
+              <a:rPr lang="en-US"/>
+              <a:t>Fourth level</a:t>
+            </a:r>
+          </a:p>
+          <a:p>
+            <a:pPr lvl="4"/>
+            <a:r>
+              <a:rPr lang="en-US"/>
+              <a:t>Fifth level</a:t>
+            </a:r>
+          </a:p>
+        </p:txBody>
+      </p:sp>
+      <p:sp>
+        <p:nvSpPr>
+          <p:cNvPr id="6" name="Footer Placeholder 5"/>
+          <p:cNvSpPr>
+            <a:spLocks noGrp="1"/>
+          </p:cNvSpPr>
+          <p:nvPr>
+            <p:ph type="ftr" sz="quarter" idx="4"/>
+          </p:nvPr>
+        </p:nvSpPr>
+        <p:spPr>
+          <a:xfrm>
+            <a:off x="0" y="8685213"/>
+            <a:ext cx="2971800" cy="458787"/>
+          </a:xfrm>
+          <a:prstGeom prst="rect">
+            <a:avLst/>
+          </a:prstGeom>
+        </p:spPr>
+        <p:txBody>
+          <a:bodyPr vert="horz" lIns="91440" tIns="45720" rIns="91440" bIns="45720" rtlCol="0" anchor="b"/>
+          <a:lstStyle>
+            <a:lvl1pPr algn="l">
+              <a:defRPr sz="1200"/>
+            </a:lvl1pPr>
+          </a:lstStyle>
+          <a:p>
+            <a:endParaRPr lang="en-US"/>
+          </a:p>
+        </p:txBody>
+      </p:sp>
+      <p:sp>
+        <p:nvSpPr>
+          <p:cNvPr id="7" name="Slide Number Placeholder 6"/>
+          <p:cNvSpPr>
+            <a:spLocks noGrp="1"/>
+          </p:cNvSpPr>
+          <p:nvPr>
+            <p:ph type="sldNum" sz="quarter" idx="5"/>
+          </p:nvPr>
+        </p:nvSpPr>
+        <p:spPr>
+          <a:xfrm>
+            <a:off x="3884613" y="8685213"/>
+            <a:ext cx="2971800" cy="458787"/>
+          </a:xfrm>
+          <a:prstGeom prst="rect">
+            <a:avLst/>
+          </a:prstGeom>
+        </p:spPr>
+        <p:txBody>
+          <a:bodyPr vert="horz" lIns="91440" tIns="45720" rIns="91440" bIns="45720" rtlCol="0" anchor="b"/>
+          <a:lstStyle>
+            <a:lvl1pPr algn="r">
+              <a:defRPr sz="1200"/>
+            </a:lvl1pPr>
+          </a:lstStyle>
+          <a:p>
+            <a:fld id="{CE5E9CC1-C706-0F49-92D6-E571CC5EEA8F}" type="slidenum">
+              <a:rPr lang="en-US"/>
+              <a:t>‹#›</a:t>
+            </a:fld>
+            <a:endParaRPr lang="en-US"/>
+          </a:p>
+        </p:txBody>
+      </p:sp>
     </p:spTree>
     <p:extLst>
       <p:ext uri="{BB962C8B-B14F-4D97-AF65-F5344CB8AC3E}">
-        <p14:creationId xmlns:p14="http://schemas.microsoft.com/office/powerpoint/2010/main" val="3210349085"/>
+        <p14:creationId xmlns:p14="http://schemas.microsoft.com/office/powerpoint/2010/main" val="1024086991"/>
       </p:ext>
     </p:extLst>
   </p:cSld>
@@ -294,6 +514,10 @@
           <a:bodyPr/>
           <a:lstStyle/>
           <a:p>
+            <a:r>
+              <a:rPr lang="en-US" dirty="0"/>
+              <a:t>Say the Aegis/shield meaning before the tech-stack line -- it's the one detail that makes the name memorable instead of generic. Pause after "Enterprise Agentic Document Intelligence Platform" before moving on.</a:t>
+            </a:r>
             <a:endParaRPr lang="en-US" dirty="0"/>
           </a:p>
         </p:txBody>
@@ -378,6 +602,10 @@
           <a:bodyPr/>
           <a:lstStyle/>
           <a:p>
+            <a:r>
+              <a:rPr lang="en-US" dirty="0"/>
+              <a:t>Read this table top to bottom once, don't paraphrase every row -- let it speak, and only elaborate on whichever row they ask about. If time is short and they only let you cover one row, pick Trust (confidence-gated abstention) -- it's the most concrete, testable claim.</a:t>
+            </a:r>
             <a:endParaRPr lang="en-US" dirty="0"/>
           </a:p>
         </p:txBody>
@@ -462,6 +690,10 @@
           <a:bodyPr/>
           <a:lstStyle/>
           <a:p>
+            <a:r>
+              <a:rPr lang="en-US" dirty="0"/>
+              <a:t>This is the credibility slide -- read it slowly. The middle card earns trust precisely because it admits a gap; don't rush past it or look uncomfortable about it. It's a strength, not a weakness, if you present it as a deliberate scoping decision.</a:t>
+            </a:r>
             <a:endParaRPr lang="en-US" dirty="0"/>
           </a:p>
         </p:txBody>
@@ -546,6 +778,10 @@
           <a:bodyPr/>
           <a:lstStyle/>
           <a:p>
+            <a:r>
+              <a:rPr lang="en-US" dirty="0"/>
+              <a:t>If asked "why not deploy it", the honest answer is on this slide: no cloud environment was provisioned for this assessment. Don't invent a technical reason -- the real reason is simply access, and the reference architecture (doc/12-cloud-reference-architecture.md) shows the plan exists.</a:t>
+            </a:r>
             <a:endParaRPr lang="en-US" dirty="0"/>
           </a:p>
         </p:txBody>
@@ -630,6 +866,10 @@
           <a:bodyPr/>
           <a:lstStyle/>
           <a:p>
+            <a:r>
+              <a:rPr lang="en-US" dirty="0"/>
+              <a:t>The two dark cards are the newest and strongest -- both backed by a live-demoable number, unlike the four lighter cards. If time is short, point at only these two and say "I can show you both of these running, right now" -- then actually do it if they take you up on it.</a:t>
+            </a:r>
             <a:endParaRPr lang="en-US" dirty="0"/>
           </a:p>
         </p:txBody>
@@ -714,6 +954,10 @@
           <a:bodyPr/>
           <a:lstStyle/>
           <a:p>
+            <a:r>
+              <a:rPr lang="en-US" dirty="0"/>
+              <a:t>If asked "why not LangGraph": this isn't unfamiliarity, it's a deliberate call. LangGraph's real strengths are state management, conditional routing and retry loops -- say that plainly. Then pivot to: the assessment mandates CrewAI, and orchestrator.py implements the same state-machine behavior LangGraph would give for free, as explicit reviewable Python instead of framework magic. On Phoenix vs LangSmith: be honest that LangSmith is likely the stronger choice on a LangChain/LangGraph-native stack -- Phoenix won here on open-source/self-hosted fit for a fully local deployment, not on being categorically better. Don't get defensive; this slide's whole point is that the tradeoff was seen and chosen, not missed.</a:t>
+            </a:r>
             <a:endParaRPr lang="en-US" dirty="0"/>
           </a:p>
         </p:txBody>
@@ -736,6 +980,94 @@
             <a:fld id="{F7021451-1387-4CA6-816F-3879F97B5CBC}" type="slidenum">
               <a:rPr lang="en-US"/>
               <a:t>14</a:t>
+            </a:fld>
+            <a:endParaRPr lang="en-US"/>
+          </a:p>
+        </p:txBody>
+      </p:sp>
+    </p:spTree>
+    <p:extLst>
+      <p:ext uri="{BB962C8B-B14F-4D97-AF65-F5344CB8AC3E}">
+        <p14:creationId xmlns:p14="http://schemas.microsoft.com/office/powerpoint/2010/main" val="1024086991"/>
+      </p:ext>
+    </p:extLst>
+  </p:cSld>
+  <p:clrMapOvr>
+    <a:masterClrMapping/>
+  </p:clrMapOvr>
+</p:notes>
+</file>
+
+<file path=ppt/notesSlides/notesSlide15.xml><?xml version="1.0" encoding="utf-8"?>
+<p:notes xmlns:a="http://schemas.openxmlformats.org/drawingml/2006/main" xmlns:r="http://schemas.openxmlformats.org/officeDocument/2006/relationships" xmlns:p="http://schemas.openxmlformats.org/presentationml/2006/main">
+  <p:cSld>
+    <p:spTree>
+      <p:nvGrpSpPr>
+        <p:cNvPr id="1" name=""/>
+        <p:cNvGrpSpPr/>
+        <p:nvPr/>
+      </p:nvGrpSpPr>
+      <p:grpSpPr>
+        <a:xfrm>
+          <a:off x="0" y="0"/>
+          <a:ext cx="0" cy="0"/>
+          <a:chOff x="0" y="0"/>
+          <a:chExt cx="0" cy="0"/>
+        </a:xfrm>
+      </p:grpSpPr>
+      <p:sp>
+        <p:nvSpPr>
+          <p:cNvPr id="2" name="Slide Image Placeholder 1"/>
+          <p:cNvSpPr>
+            <a:spLocks noGrp="1" noRot="1" noChangeAspect="1"/>
+          </p:cNvSpPr>
+          <p:nvPr>
+            <p:ph type="sldImg"/>
+          </p:nvPr>
+        </p:nvSpPr>
+        <p:spPr/>
+      </p:sp>
+      <p:sp>
+        <p:nvSpPr>
+          <p:cNvPr id="3" name="Notes Placeholder 2"/>
+          <p:cNvSpPr>
+            <a:spLocks noGrp="1"/>
+          </p:cNvSpPr>
+          <p:nvPr>
+            <p:ph type="body" idx="1"/>
+          </p:nvPr>
+        </p:nvSpPr>
+        <p:spPr/>
+        <p:txBody>
+          <a:bodyPr/>
+          <a:lstStyle/>
+          <a:p>
+            <a:r>
+              <a:rPr lang="en-US" dirty="0"/>
+              <a:t>End here, then stop talking and take questions -- don't keep selling after this slide. If they ask "what would you do with one more week", the three cards above are your ready-made answer.</a:t>
+            </a:r>
+            <a:endParaRPr lang="en-US" dirty="0"/>
+          </a:p>
+        </p:txBody>
+      </p:sp>
+      <p:sp>
+        <p:nvSpPr>
+          <p:cNvPr id="4" name="Slide Number Placeholder 3"/>
+          <p:cNvSpPr>
+            <a:spLocks noGrp="1"/>
+          </p:cNvSpPr>
+          <p:nvPr>
+            <p:ph type="sldNum" sz="quarter" idx="10"/>
+          </p:nvPr>
+        </p:nvSpPr>
+        <p:spPr/>
+        <p:txBody>
+          <a:bodyPr/>
+          <a:lstStyle/>
+          <a:p>
+            <a:fld id="{F7021451-1387-4CA6-816F-3879F97B5CBC}" type="slidenum">
+              <a:rPr lang="en-US"/>
+              <a:t>15</a:t>
             </a:fld>
             <a:endParaRPr lang="en-US"/>
           </a:p>
@@ -798,6 +1130,10 @@
           <a:bodyPr/>
           <a:lstStyle/>
           <a:p>
+            <a:r>
+              <a:rPr lang="en-US" dirty="0"/>
+              <a:t>This 8-step chain is the one sentence that summarizes the whole system if asked "what does this do" cold. Memorize the order: Ingest, Retrieve, Reason, Validate, Cite, Observe, Evaluate, Improve.</a:t>
+            </a:r>
             <a:endParaRPr lang="en-US" dirty="0"/>
           </a:p>
         </p:txBody>
@@ -882,6 +1218,10 @@
           <a:bodyPr/>
           <a:lstStyle/>
           <a:p>
+            <a:r>
+              <a:rPr lang="en-US" dirty="0"/>
+              <a:t>If asked to pick the single most important plane, say Trust &amp; Governance -- that's what the Aegis name is actually about, not just retrieval. Knowledge and AI Runtime are what most fresher projects have; the bottom row is the differentiator.</a:t>
+            </a:r>
             <a:endParaRPr lang="en-US" dirty="0"/>
           </a:p>
         </p:txBody>
@@ -966,6 +1306,10 @@
           <a:bodyPr/>
           <a:lstStyle/>
           <a:p>
+            <a:r>
+              <a:rPr lang="en-US" dirty="0"/>
+              <a:t>All four numbers are real, measured on this exact corpus -- not example numbers. Say so if asked. The "0" card is checksum-based dedupe: re-running ingestion on an unchanged file is a verified no-op, tested in tests/integration/test_ingestion_dedupe.py.</a:t>
+            </a:r>
             <a:endParaRPr lang="en-US" dirty="0"/>
           </a:p>
         </p:txBody>
@@ -1050,6 +1394,10 @@
           <a:bodyPr/>
           <a:lstStyle/>
           <a:p>
+            <a:r>
+              <a:rPr lang="en-US" dirty="0"/>
+              <a:t>Good slide to reference right before your live question -- say "watch, this loop is about to run" then switch to OpenWebUI. Worth mentioning here that 2 of these 5 steps (Planner, Evidence Validator) can be skipped by a fast heuristic instead of an LLM call -- see the cheat sheet's smart-bypass section for the exact numbers (107.8s vs 58.3s) if asked why it's not always all 5.</a:t>
+            </a:r>
             <a:endParaRPr lang="en-US" dirty="0"/>
           </a:p>
         </p:txBody>
@@ -1134,6 +1482,10 @@
           <a:bodyPr/>
           <a:lstStyle/>
           <a:p>
+            <a:r>
+              <a:rPr lang="en-US" dirty="0"/>
+              <a:t>This is a real captured OpenWebUI session, not written for the deck. If your live demo answer differs in wording, that's fine -- say "same shape as what you're about to see live", don't apologize for it being different.</a:t>
+            </a:r>
             <a:endParaRPr lang="en-US" dirty="0"/>
           </a:p>
         </p:txBody>
@@ -1218,6 +1570,10 @@
           <a:bodyPr/>
           <a:lstStyle/>
           <a:p>
+            <a:r>
+              <a:rPr lang="en-US" dirty="0"/>
+              <a:t>The dark statement slide -- pause here, don't rush. If asked to pick one thing that proves this isn't just a chatbot, point at this slide. The audit log lives in Postgres (table audit_log) -- see the cheat sheet section 13a for the exact columns (event_hash, previous_event_hash, policy_version) and the make verify-audit command to prove it live.</a:t>
+            </a:r>
             <a:endParaRPr lang="en-US" dirty="0"/>
           </a:p>
         </p:txBody>
@@ -1302,6 +1658,10 @@
           <a:bodyPr/>
           <a:lstStyle/>
           <a:p>
+            <a:r>
+              <a:rPr lang="en-US" dirty="0"/>
+              <a:t>Cue to actually open Phoenix right after this slide -- say "let me show you" and switch live rather than just describing spans. See cheat sheet section 12 for the click-by-click path. If smart bypass or the cache fired during your demo, this trace will show fewer spans than the "4 LLM calls" claimed here -- point that out as visual proof, not a contradiction.</a:t>
+            </a:r>
             <a:endParaRPr lang="en-US" dirty="0"/>
           </a:p>
         </p:txBody>
@@ -1386,6 +1746,10 @@
           <a:bodyPr/>
           <a:lstStyle/>
           <a:p>
+            <a:r>
+              <a:rPr lang="en-US" dirty="0"/>
+              <a:t>Be honest if pushed on scale: the golden set is small (4 questions on 1 document) -- say so plainly rather than let the metric names imply more coverage than there is. The mechanism (RAGAs harness + saved baseline in evaluation/run.py) is real and complete; the dataset is what's small.</a:t>
+            </a:r>
             <a:endParaRPr lang="en-US" dirty="0"/>
           </a:p>
         </p:txBody>
@@ -1459,11 +1823,6 @@
 <file path=ppt/slideMasters/slideMaster1.xml><?xml version="1.0" encoding="utf-8"?>
 <p:sldMaster xmlns:a="http://schemas.openxmlformats.org/drawingml/2006/main" xmlns:r="http://schemas.openxmlformats.org/officeDocument/2006/relationships" xmlns:p="http://schemas.openxmlformats.org/presentationml/2006/main">
   <p:cSld>
-    <p:bg>
-      <p:bgRef idx="1001">
-        <a:schemeClr val="bg1"/>
-      </p:bgRef>
-    </p:bg>
     <p:spTree>
       <p:nvGrpSpPr>
         <p:cNvPr id="1" name=""/>
@@ -1746,7 +2105,6 @@
         <a:solidFill>
           <a:srgbClr val="FBFBF8"/>
         </a:solidFill>
-        <a:effectLst/>
       </p:bgPr>
     </p:bg>
     <p:spTree>
@@ -1765,15 +2123,15 @@
       </p:grpSpPr>
       <p:pic>
         <p:nvPicPr>
-          <p:cNvPr id="2" name="Image 0" descr="rect"/>
+          <p:cNvPr id="2" name="Image 0" descr="rect">    </p:cNvPr>
           <p:cNvPicPr>
             <a:picLocks noChangeAspect="1"/>
           </p:cNvPicPr>
           <p:nvPr/>
         </p:nvPicPr>
         <p:blipFill>
-          <a:blip r:embed="rId3"/>
-          <a:srcRect/>
+          <a:blip r:embed="rId1"/>
+          <a:srcRect l="0" r="0" t="0" b="0"/>
           <a:stretch/>
         </p:blipFill>
         <p:spPr>
@@ -1809,14 +2167,14 @@
           </a:bodyPr>
           <a:lstStyle/>
           <a:p>
-            <a:pPr marL="0" indent="0" algn="l">
+            <a:pPr algn="l" indent="0" marL="0">
               <a:lnSpc>
                 <a:spcPts val="1960"/>
               </a:lnSpc>
               <a:buNone/>
             </a:pPr>
             <a:r>
-              <a:rPr lang="en-US" sz="1400" b="1" kern="0" spc="200" dirty="0">
+              <a:rPr lang="en-US" sz="1400" b="1" spc="200" kern="0" dirty="0">
                 <a:solidFill>
                   <a:srgbClr val="B08D57"/>
                 </a:solidFill>
@@ -1853,7 +2211,7 @@
           </a:bodyPr>
           <a:lstStyle/>
           <a:p>
-            <a:pPr marL="0" indent="0" algn="l">
+            <a:pPr algn="l" indent="0" marL="0">
               <a:lnSpc>
                 <a:spcPts val="8000"/>
               </a:lnSpc>
@@ -1897,7 +2255,7 @@
           </a:bodyPr>
           <a:lstStyle/>
           <a:p>
-            <a:pPr marL="0" indent="0" algn="l">
+            <a:pPr algn="l" indent="0" marL="0">
               <a:lnSpc>
                 <a:spcPts val="2640"/>
               </a:lnSpc>
@@ -1968,7 +2326,7 @@
           </a:bodyPr>
           <a:lstStyle/>
           <a:p>
-            <a:pPr marL="0" indent="0" algn="l">
+            <a:pPr algn="l" indent="0" marL="0">
               <a:lnSpc>
                 <a:spcPts val="1800"/>
               </a:lnSpc>
@@ -2045,7 +2403,7 @@
           </a:bodyPr>
           <a:lstStyle/>
           <a:p>
-            <a:pPr marL="0" indent="0" algn="l">
+            <a:pPr algn="l" indent="0" marL="0">
               <a:lnSpc>
                 <a:spcPts val="1800"/>
               </a:lnSpc>
@@ -2089,7 +2447,7 @@
           </a:bodyPr>
           <a:lstStyle/>
           <a:p>
-            <a:pPr marL="0" indent="0" algn="l">
+            <a:pPr algn="l" indent="0" marL="0">
               <a:lnSpc>
                 <a:spcPts val="1960"/>
               </a:lnSpc>
@@ -2129,18 +2487,18 @@
         </p:spPr>
         <p:txBody>
           <a:bodyPr wrap="square" lIns="0" tIns="0" rIns="0" bIns="0" rtlCol="0" anchor="t">
-            <a:noAutofit/>
-          </a:bodyPr>
-          <a:lstStyle/>
-          <a:p>
-            <a:pPr marL="0" indent="0" algn="l">
+            <a:normAutofit/>
+          </a:bodyPr>
+          <a:lstStyle/>
+          <a:p>
+            <a:pPr algn="l" indent="0" marL="0">
               <a:lnSpc>
                 <a:spcPts val="1610"/>
               </a:lnSpc>
               <a:buNone/>
             </a:pPr>
             <a:r>
-              <a:rPr lang="en-US" sz="900" kern="0" spc="50" dirty="0">
+              <a:rPr lang="en-US" sz="1150" spc="50" kern="0" dirty="0">
                 <a:solidFill>
                   <a:srgbClr val="5B6472"/>
                 </a:solidFill>
@@ -2150,38 +2508,7 @@
               </a:rPr>
               <a:t>Docling · LlamaIndex · CrewAI · PostgreSQL / PGVector · Ollama · Arize Phoenix · RAGAs</a:t>
             </a:r>
-          </a:p>
-          <a:p>
-            <a:pPr marL="0" indent="0" algn="l">
-              <a:lnSpc>
-                <a:spcPts val="1610"/>
-              </a:lnSpc>
-              <a:buNone/>
-            </a:pPr>
-            <a:endParaRPr lang="en-US" sz="900" kern="0" spc="50" dirty="0">
-              <a:solidFill>
-                <a:srgbClr val="5B6472"/>
-              </a:solidFill>
-              <a:latin typeface="IBM Plex Sans" pitchFamily="34" charset="0"/>
-            </a:endParaRPr>
-          </a:p>
-          <a:p>
-            <a:pPr marL="0" indent="0" algn="l">
-              <a:lnSpc>
-                <a:spcPts val="1610"/>
-              </a:lnSpc>
-              <a:buNone/>
-            </a:pPr>
-            <a:r>
-              <a:rPr lang="en-US" sz="900" kern="0" spc="50" dirty="0">
-                <a:solidFill>
-                  <a:srgbClr val="5B6472"/>
-                </a:solidFill>
-                <a:latin typeface="IBM Plex Sans" pitchFamily="34" charset="0"/>
-              </a:rPr>
-              <a:t>By Dr. Munmun Das</a:t>
-            </a:r>
-            <a:endParaRPr lang="en-US" sz="900" dirty="0"/>
+            <a:endParaRPr lang="en-US" sz="1150" dirty="0"/>
           </a:p>
         </p:txBody>
       </p:sp>
@@ -2201,7 +2528,6 @@
         <a:solidFill>
           <a:srgbClr val="FBFBF8"/>
         </a:solidFill>
-        <a:effectLst/>
       </p:bgPr>
     </p:bg>
     <p:spTree>
@@ -2241,14 +2567,14 @@
           </a:bodyPr>
           <a:lstStyle/>
           <a:p>
-            <a:pPr marL="0" indent="0" algn="l">
+            <a:pPr algn="l" indent="0" marL="0">
               <a:lnSpc>
                 <a:spcPts val="1680"/>
               </a:lnSpc>
               <a:buNone/>
             </a:pPr>
             <a:r>
-              <a:rPr lang="en-US" sz="1200" b="1" kern="0" spc="150" dirty="0">
+              <a:rPr lang="en-US" sz="1200" b="1" spc="150" kern="0" dirty="0">
                 <a:solidFill>
                   <a:srgbClr val="B08D57"/>
                 </a:solidFill>
@@ -2285,7 +2611,7 @@
           </a:bodyPr>
           <a:lstStyle/>
           <a:p>
-            <a:pPr marL="0" indent="0" algn="l">
+            <a:pPr algn="l" indent="0" marL="0">
               <a:lnSpc>
                 <a:spcPts val="3450"/>
               </a:lnSpc>
@@ -2315,41 +2641,23 @@
           <p:nvPr>
             <p:extLst>
               <p:ext uri="{D42A27DB-BD31-4B8C-83A1-F6EECF244321}">
-                <p14:modId xmlns:p14="http://schemas.microsoft.com/office/powerpoint/2010/main" val="3257816790"/>
+                <p14:modId xmlns:p14="http://schemas.microsoft.com/office/powerpoint/2010/main" val="1579011935"/>
               </p:ext>
             </p:extLst>
           </p:nvPr>
         </p:nvGraphicFramePr>
         <p:xfrm>
           <a:off x="812800" y="1921470"/>
-          <a:ext cx="10566400" cy="3907828"/>
+          <a:ext cx="10566400" cy="3907830"/>
         </p:xfrm>
         <a:graphic>
           <a:graphicData uri="http://schemas.openxmlformats.org/drawingml/2006/table">
             <a:tbl>
               <a:tblPr/>
               <a:tblGrid>
-                <a:gridCol w="2747264">
-                  <a:extLst>
-                    <a:ext uri="{9D8B030D-6E8A-4147-A177-3AD203B41FA5}">
-                      <a16:colId xmlns:a16="http://schemas.microsoft.com/office/drawing/2014/main" val="20000"/>
-                    </a:ext>
-                  </a:extLst>
-                </a:gridCol>
-                <a:gridCol w="3909568">
-                  <a:extLst>
-                    <a:ext uri="{9D8B030D-6E8A-4147-A177-3AD203B41FA5}">
-                      <a16:colId xmlns:a16="http://schemas.microsoft.com/office/drawing/2014/main" val="20001"/>
-                    </a:ext>
-                  </a:extLst>
-                </a:gridCol>
-                <a:gridCol w="3909568">
-                  <a:extLst>
-                    <a:ext uri="{9D8B030D-6E8A-4147-A177-3AD203B41FA5}">
-                      <a16:colId xmlns:a16="http://schemas.microsoft.com/office/drawing/2014/main" val="20002"/>
-                    </a:ext>
-                  </a:extLst>
-                </a:gridCol>
+                <a:gridCol w="2747264"/>
+                <a:gridCol w="3909568"/>
+                <a:gridCol w="3909568"/>
               </a:tblGrid>
               <a:tr h="651272">
                 <a:tc>
@@ -2357,7 +2665,7 @@
                     <a:bodyPr/>
                     <a:lstStyle/>
                     <a:p>
-                      <a:pPr marL="0" indent="0">
+                      <a:pPr indent="0" marL="0">
                         <a:lnSpc>
                           <a:spcPts val="1680"/>
                         </a:lnSpc>
@@ -2381,7 +2689,7 @@
                       </a:endParaRPr>
                     </a:p>
                   </a:txBody>
-                  <a:tcPr marL="53340" marR="53340" marT="53340" marB="53340">
+                  <a:tcPr marL="53340" marR="53340" marT="53340" marB="53340" anchor="t">
                     <a:lnL w="12700" cap="flat" cmpd="sng" algn="ctr">
                       <a:solidFill>
                         <a:srgbClr val="CACBCD"/>
@@ -2428,7 +2736,7 @@
                     <a:bodyPr/>
                     <a:lstStyle/>
                     <a:p>
-                      <a:pPr marL="0" indent="0">
+                      <a:pPr indent="0" marL="0">
                         <a:lnSpc>
                           <a:spcPts val="1680"/>
                         </a:lnSpc>
@@ -2443,7 +2751,7 @@
                           <a:ea typeface="IBM Plex Sans" pitchFamily="34" charset="-122"/>
                           <a:cs typeface="IBM Plex Sans" pitchFamily="34" charset="-120"/>
                         </a:rPr>
-                        <a:t>General / Beginner’s approach</a:t>
+                        <a:t>Fresher approach</a:t>
                       </a:r>
                       <a:endParaRPr lang="en-US" sz="1200" dirty="0">
                         <a:latin typeface="IBM Plex Sans" charset="0"/>
@@ -2452,7 +2760,7 @@
                       </a:endParaRPr>
                     </a:p>
                   </a:txBody>
-                  <a:tcPr marL="53340" marR="53340" marT="53340" marB="53340">
+                  <a:tcPr marL="53340" marR="53340" marT="53340" marB="53340" anchor="t">
                     <a:lnL w="12700" cap="flat" cmpd="sng" algn="ctr">
                       <a:solidFill>
                         <a:srgbClr val="CACBCD"/>
@@ -2499,7 +2807,7 @@
                     <a:bodyPr/>
                     <a:lstStyle/>
                     <a:p>
-                      <a:pPr marL="0" indent="0">
+                      <a:pPr indent="0" marL="0">
                         <a:lnSpc>
                           <a:spcPts val="1680"/>
                         </a:lnSpc>
@@ -2523,7 +2831,7 @@
                       </a:endParaRPr>
                     </a:p>
                   </a:txBody>
-                  <a:tcPr marL="53340" marR="53340" marT="53340" marB="53340">
+                  <a:tcPr marL="53340" marR="53340" marT="53340" marB="53340" anchor="t">
                     <a:lnL w="12700" cap="flat" cmpd="sng" algn="ctr">
                       <a:solidFill>
                         <a:srgbClr val="CACBCD"/>
@@ -2565,11 +2873,6 @@
                     </a:solidFill>
                   </a:tcPr>
                 </a:tc>
-                <a:extLst>
-                  <a:ext uri="{0D108BD9-81ED-4DB2-BD59-A6C34878D82A}">
-                    <a16:rowId xmlns:a16="http://schemas.microsoft.com/office/drawing/2014/main" val="10000"/>
-                  </a:ext>
-                </a:extLst>
               </a:tr>
               <a:tr h="651272">
                 <a:tc>
@@ -2577,7 +2880,7 @@
                     <a:bodyPr/>
                     <a:lstStyle/>
                     <a:p>
-                      <a:pPr marL="0" indent="0">
+                      <a:pPr indent="0" marL="0">
                         <a:lnSpc>
                           <a:spcPts val="1680"/>
                         </a:lnSpc>
@@ -2601,7 +2904,7 @@
                       </a:endParaRPr>
                     </a:p>
                   </a:txBody>
-                  <a:tcPr marL="53340" marR="53340" marT="53340" marB="53340">
+                  <a:tcPr marL="53340" marR="53340" marT="53340" marB="53340" anchor="t">
                     <a:lnL w="12700" cap="flat" cmpd="sng" algn="ctr">
                       <a:solidFill>
                         <a:srgbClr val="CACBCD"/>
@@ -2648,7 +2951,7 @@
                     <a:bodyPr/>
                     <a:lstStyle/>
                     <a:p>
-                      <a:pPr marL="0" indent="0">
+                      <a:pPr indent="0" marL="0">
                         <a:lnSpc>
                           <a:spcPts val="1680"/>
                         </a:lnSpc>
@@ -2672,7 +2975,7 @@
                       </a:endParaRPr>
                     </a:p>
                   </a:txBody>
-                  <a:tcPr marL="53340" marR="53340" marT="53340" marB="53340">
+                  <a:tcPr marL="53340" marR="53340" marT="53340" marB="53340" anchor="t">
                     <a:lnL w="12700" cap="flat" cmpd="sng" algn="ctr">
                       <a:solidFill>
                         <a:srgbClr val="CACBCD"/>
@@ -2719,7 +3022,7 @@
                     <a:bodyPr/>
                     <a:lstStyle/>
                     <a:p>
-                      <a:pPr marL="0" indent="0">
+                      <a:pPr indent="0" marL="0">
                         <a:lnSpc>
                           <a:spcPts val="1680"/>
                         </a:lnSpc>
@@ -2743,7 +3046,7 @@
                       </a:endParaRPr>
                     </a:p>
                   </a:txBody>
-                  <a:tcPr marL="53340" marR="53340" marT="53340" marB="53340">
+                  <a:tcPr marL="53340" marR="53340" marT="53340" marB="53340" anchor="t">
                     <a:lnL w="12700" cap="flat" cmpd="sng" algn="ctr">
                       <a:solidFill>
                         <a:srgbClr val="CACBCD"/>
@@ -2785,11 +3088,6 @@
                     </a:solidFill>
                   </a:tcPr>
                 </a:tc>
-                <a:extLst>
-                  <a:ext uri="{0D108BD9-81ED-4DB2-BD59-A6C34878D82A}">
-                    <a16:rowId xmlns:a16="http://schemas.microsoft.com/office/drawing/2014/main" val="10001"/>
-                  </a:ext>
-                </a:extLst>
               </a:tr>
               <a:tr h="651321">
                 <a:tc>
@@ -2797,7 +3095,7 @@
                     <a:bodyPr/>
                     <a:lstStyle/>
                     <a:p>
-                      <a:pPr marL="0" indent="0">
+                      <a:pPr indent="0" marL="0">
                         <a:lnSpc>
                           <a:spcPts val="1680"/>
                         </a:lnSpc>
@@ -2821,7 +3119,7 @@
                       </a:endParaRPr>
                     </a:p>
                   </a:txBody>
-                  <a:tcPr marL="53340" marR="53340" marT="53340" marB="53340">
+                  <a:tcPr marL="53340" marR="53340" marT="53340" marB="53340" anchor="t">
                     <a:lnL w="12700" cap="flat" cmpd="sng" algn="ctr">
                       <a:solidFill>
                         <a:srgbClr val="CACBCD"/>
@@ -2868,7 +3166,7 @@
                     <a:bodyPr/>
                     <a:lstStyle/>
                     <a:p>
-                      <a:pPr marL="0" indent="0">
+                      <a:pPr indent="0" marL="0">
                         <a:lnSpc>
                           <a:spcPts val="1680"/>
                         </a:lnSpc>
@@ -2892,7 +3190,7 @@
                       </a:endParaRPr>
                     </a:p>
                   </a:txBody>
-                  <a:tcPr marL="53340" marR="53340" marT="53340" marB="53340">
+                  <a:tcPr marL="53340" marR="53340" marT="53340" marB="53340" anchor="t">
                     <a:lnL w="12700" cap="flat" cmpd="sng" algn="ctr">
                       <a:solidFill>
                         <a:srgbClr val="CACBCD"/>
@@ -2939,7 +3237,7 @@
                     <a:bodyPr/>
                     <a:lstStyle/>
                     <a:p>
-                      <a:pPr marL="0" indent="0">
+                      <a:pPr indent="0" marL="0">
                         <a:lnSpc>
                           <a:spcPts val="1680"/>
                         </a:lnSpc>
@@ -2963,7 +3261,7 @@
                       </a:endParaRPr>
                     </a:p>
                   </a:txBody>
-                  <a:tcPr marL="53340" marR="53340" marT="53340" marB="53340">
+                  <a:tcPr marL="53340" marR="53340" marT="53340" marB="53340" anchor="t">
                     <a:lnL w="12700" cap="flat" cmpd="sng" algn="ctr">
                       <a:solidFill>
                         <a:srgbClr val="CACBCD"/>
@@ -3005,11 +3303,6 @@
                     </a:solidFill>
                   </a:tcPr>
                 </a:tc>
-                <a:extLst>
-                  <a:ext uri="{0D108BD9-81ED-4DB2-BD59-A6C34878D82A}">
-                    <a16:rowId xmlns:a16="http://schemas.microsoft.com/office/drawing/2014/main" val="10002"/>
-                  </a:ext>
-                </a:extLst>
               </a:tr>
               <a:tr h="651321">
                 <a:tc>
@@ -3017,7 +3310,7 @@
                     <a:bodyPr/>
                     <a:lstStyle/>
                     <a:p>
-                      <a:pPr marL="0" indent="0">
+                      <a:pPr indent="0" marL="0">
                         <a:lnSpc>
                           <a:spcPts val="1680"/>
                         </a:lnSpc>
@@ -3041,7 +3334,7 @@
                       </a:endParaRPr>
                     </a:p>
                   </a:txBody>
-                  <a:tcPr marL="53340" marR="53340" marT="53340" marB="53340">
+                  <a:tcPr marL="53340" marR="53340" marT="53340" marB="53340" anchor="t">
                     <a:lnL w="12700" cap="flat" cmpd="sng" algn="ctr">
                       <a:solidFill>
                         <a:srgbClr val="CACBCD"/>
@@ -3088,7 +3381,7 @@
                     <a:bodyPr/>
                     <a:lstStyle/>
                     <a:p>
-                      <a:pPr marL="0" indent="0">
+                      <a:pPr indent="0" marL="0">
                         <a:lnSpc>
                           <a:spcPts val="1680"/>
                         </a:lnSpc>
@@ -3112,7 +3405,7 @@
                       </a:endParaRPr>
                     </a:p>
                   </a:txBody>
-                  <a:tcPr marL="53340" marR="53340" marT="53340" marB="53340">
+                  <a:tcPr marL="53340" marR="53340" marT="53340" marB="53340" anchor="t">
                     <a:lnL w="12700" cap="flat" cmpd="sng" algn="ctr">
                       <a:solidFill>
                         <a:srgbClr val="CACBCD"/>
@@ -3159,7 +3452,7 @@
                     <a:bodyPr/>
                     <a:lstStyle/>
                     <a:p>
-                      <a:pPr marL="0" indent="0">
+                      <a:pPr indent="0" marL="0">
                         <a:lnSpc>
                           <a:spcPts val="1680"/>
                         </a:lnSpc>
@@ -3183,7 +3476,7 @@
                       </a:endParaRPr>
                     </a:p>
                   </a:txBody>
-                  <a:tcPr marL="53340" marR="53340" marT="53340" marB="53340">
+                  <a:tcPr marL="53340" marR="53340" marT="53340" marB="53340" anchor="t">
                     <a:lnL w="12700" cap="flat" cmpd="sng" algn="ctr">
                       <a:solidFill>
                         <a:srgbClr val="CACBCD"/>
@@ -3225,11 +3518,6 @@
                     </a:solidFill>
                   </a:tcPr>
                 </a:tc>
-                <a:extLst>
-                  <a:ext uri="{0D108BD9-81ED-4DB2-BD59-A6C34878D82A}">
-                    <a16:rowId xmlns:a16="http://schemas.microsoft.com/office/drawing/2014/main" val="10003"/>
-                  </a:ext>
-                </a:extLst>
               </a:tr>
               <a:tr h="651321">
                 <a:tc>
@@ -3237,7 +3525,7 @@
                     <a:bodyPr/>
                     <a:lstStyle/>
                     <a:p>
-                      <a:pPr marL="0" indent="0">
+                      <a:pPr indent="0" marL="0">
                         <a:lnSpc>
                           <a:spcPts val="1680"/>
                         </a:lnSpc>
@@ -3261,7 +3549,7 @@
                       </a:endParaRPr>
                     </a:p>
                   </a:txBody>
-                  <a:tcPr marL="53340" marR="53340" marT="53340" marB="53340">
+                  <a:tcPr marL="53340" marR="53340" marT="53340" marB="53340" anchor="t">
                     <a:lnL w="12700" cap="flat" cmpd="sng" algn="ctr">
                       <a:solidFill>
                         <a:srgbClr val="CACBCD"/>
@@ -3308,7 +3596,7 @@
                     <a:bodyPr/>
                     <a:lstStyle/>
                     <a:p>
-                      <a:pPr marL="0" indent="0">
+                      <a:pPr indent="0" marL="0">
                         <a:lnSpc>
                           <a:spcPts val="1680"/>
                         </a:lnSpc>
@@ -3332,7 +3620,7 @@
                       </a:endParaRPr>
                     </a:p>
                   </a:txBody>
-                  <a:tcPr marL="53340" marR="53340" marT="53340" marB="53340">
+                  <a:tcPr marL="53340" marR="53340" marT="53340" marB="53340" anchor="t">
                     <a:lnL w="12700" cap="flat" cmpd="sng" algn="ctr">
                       <a:solidFill>
                         <a:srgbClr val="CACBCD"/>
@@ -3379,7 +3667,7 @@
                     <a:bodyPr/>
                     <a:lstStyle/>
                     <a:p>
-                      <a:pPr marL="0" indent="0">
+                      <a:pPr indent="0" marL="0">
                         <a:lnSpc>
                           <a:spcPts val="1680"/>
                         </a:lnSpc>
@@ -3403,7 +3691,7 @@
                       </a:endParaRPr>
                     </a:p>
                   </a:txBody>
-                  <a:tcPr marL="53340" marR="53340" marT="53340" marB="53340">
+                  <a:tcPr marL="53340" marR="53340" marT="53340" marB="53340" anchor="t">
                     <a:lnL w="12700" cap="flat" cmpd="sng" algn="ctr">
                       <a:solidFill>
                         <a:srgbClr val="CACBCD"/>
@@ -3445,11 +3733,6 @@
                     </a:solidFill>
                   </a:tcPr>
                 </a:tc>
-                <a:extLst>
-                  <a:ext uri="{0D108BD9-81ED-4DB2-BD59-A6C34878D82A}">
-                    <a16:rowId xmlns:a16="http://schemas.microsoft.com/office/drawing/2014/main" val="10004"/>
-                  </a:ext>
-                </a:extLst>
               </a:tr>
               <a:tr h="651321">
                 <a:tc>
@@ -3457,7 +3740,7 @@
                     <a:bodyPr/>
                     <a:lstStyle/>
                     <a:p>
-                      <a:pPr marL="0" indent="0">
+                      <a:pPr indent="0" marL="0">
                         <a:lnSpc>
                           <a:spcPts val="1680"/>
                         </a:lnSpc>
@@ -3481,7 +3764,7 @@
                       </a:endParaRPr>
                     </a:p>
                   </a:txBody>
-                  <a:tcPr marL="53340" marR="53340" marT="53340" marB="53340">
+                  <a:tcPr marL="53340" marR="53340" marT="53340" marB="53340" anchor="t">
                     <a:lnL w="12700" cap="flat" cmpd="sng" algn="ctr">
                       <a:solidFill>
                         <a:srgbClr val="CACBCD"/>
@@ -3528,7 +3811,7 @@
                     <a:bodyPr/>
                     <a:lstStyle/>
                     <a:p>
-                      <a:pPr marL="0" indent="0">
+                      <a:pPr indent="0" marL="0">
                         <a:lnSpc>
                           <a:spcPts val="1680"/>
                         </a:lnSpc>
@@ -3552,7 +3835,7 @@
                       </a:endParaRPr>
                     </a:p>
                   </a:txBody>
-                  <a:tcPr marL="53340" marR="53340" marT="53340" marB="53340">
+                  <a:tcPr marL="53340" marR="53340" marT="53340" marB="53340" anchor="t">
                     <a:lnL w="12700" cap="flat" cmpd="sng" algn="ctr">
                       <a:solidFill>
                         <a:srgbClr val="CACBCD"/>
@@ -3599,7 +3882,7 @@
                     <a:bodyPr/>
                     <a:lstStyle/>
                     <a:p>
-                      <a:pPr marL="0" indent="0">
+                      <a:pPr indent="0" marL="0">
                         <a:lnSpc>
                           <a:spcPts val="1680"/>
                         </a:lnSpc>
@@ -3623,7 +3906,7 @@
                       </a:endParaRPr>
                     </a:p>
                   </a:txBody>
-                  <a:tcPr marL="53340" marR="53340" marT="53340" marB="53340">
+                  <a:tcPr marL="53340" marR="53340" marT="53340" marB="53340" anchor="t">
                     <a:lnL w="12700" cap="flat" cmpd="sng" algn="ctr">
                       <a:solidFill>
                         <a:srgbClr val="CACBCD"/>
@@ -3665,11 +3948,6 @@
                     </a:solidFill>
                   </a:tcPr>
                 </a:tc>
-                <a:extLst>
-                  <a:ext uri="{0D108BD9-81ED-4DB2-BD59-A6C34878D82A}">
-                    <a16:rowId xmlns:a16="http://schemas.microsoft.com/office/drawing/2014/main" val="10005"/>
-                  </a:ext>
-                </a:extLst>
               </a:tr>
             </a:tbl>
           </a:graphicData>
@@ -3698,7 +3976,7 @@
           </a:bodyPr>
           <a:lstStyle/>
           <a:p>
-            <a:pPr marL="0" indent="0" algn="l">
+            <a:pPr algn="l" indent="0" marL="0">
               <a:lnSpc>
                 <a:spcPts val="1680"/>
               </a:lnSpc>
@@ -3742,7 +4020,7 @@
           </a:bodyPr>
           <a:lstStyle/>
           <a:p>
-            <a:pPr marL="0" indent="0" algn="l">
+            <a:pPr algn="l" indent="0" marL="0">
               <a:lnSpc>
                 <a:spcPts val="1680"/>
               </a:lnSpc>
@@ -3757,7 +4035,7 @@
                 <a:ea typeface="IBM Plex Sans" pitchFamily="34" charset="-122"/>
                 <a:cs typeface="IBM Plex Sans" pitchFamily="34" charset="-120"/>
               </a:rPr>
-              <a:t>10 / 14</a:t>
+              <a:t>10 / 15</a:t>
             </a:r>
             <a:endParaRPr lang="en-US" sz="1200" dirty="0"/>
           </a:p>
@@ -3779,7 +4057,6 @@
         <a:solidFill>
           <a:srgbClr val="F0EFE9"/>
         </a:solidFill>
-        <a:effectLst/>
       </p:bgPr>
     </p:bg>
     <p:spTree>
@@ -3819,14 +4096,14 @@
           </a:bodyPr>
           <a:lstStyle/>
           <a:p>
-            <a:pPr marL="0" indent="0" algn="l">
+            <a:pPr algn="l" indent="0" marL="0">
               <a:lnSpc>
                 <a:spcPts val="1680"/>
               </a:lnSpc>
               <a:buNone/>
             </a:pPr>
             <a:r>
-              <a:rPr lang="en-US" sz="1200" b="1" kern="0" spc="150" dirty="0">
+              <a:rPr lang="en-US" sz="1200" b="1" spc="150" kern="0" dirty="0">
                 <a:solidFill>
                   <a:srgbClr val="B08D57"/>
                 </a:solidFill>
@@ -3863,7 +4140,7 @@
           </a:bodyPr>
           <a:lstStyle/>
           <a:p>
-            <a:pPr marL="0" indent="0" algn="l">
+            <a:pPr algn="l" indent="0" marL="0">
               <a:lnSpc>
                 <a:spcPts val="3220"/>
               </a:lnSpc>
@@ -3908,15 +4185,15 @@
       </p:sp>
       <p:pic>
         <p:nvPicPr>
-          <p:cNvPr id="5" name="Image 0" descr="CheckCircle"/>
+          <p:cNvPr id="5" name="Image 0" descr="CheckCircle">    </p:cNvPr>
           <p:cNvPicPr>
             <a:picLocks noChangeAspect="1"/>
           </p:cNvPicPr>
           <p:nvPr/>
         </p:nvPicPr>
         <p:blipFill>
-          <a:blip r:embed="rId3"/>
-          <a:srcRect/>
+          <a:blip r:embed="rId1"/>
+          <a:srcRect l="0" r="0" t="0" b="0"/>
           <a:stretch/>
         </p:blipFill>
         <p:spPr>
@@ -3952,7 +4229,7 @@
           </a:bodyPr>
           <a:lstStyle/>
           <a:p>
-            <a:pPr marL="0" indent="0" algn="l">
+            <a:pPr algn="l" indent="0" marL="0">
               <a:lnSpc>
                 <a:spcPts val="1560"/>
               </a:lnSpc>
@@ -3996,7 +4273,7 @@
           </a:bodyPr>
           <a:lstStyle/>
           <a:p>
-            <a:pPr marL="0" indent="0" algn="l">
+            <a:pPr algn="l" indent="0" marL="0">
               <a:lnSpc>
                 <a:spcPts val="1550"/>
               </a:lnSpc>
@@ -4011,7 +4288,7 @@
                 <a:ea typeface="IBM Plex Sans" pitchFamily="34" charset="-122"/>
                 <a:cs typeface="IBM Plex Sans" pitchFamily="34" charset="-120"/>
               </a:rPr>
-              <a:t>Ingestion · hybrid retrieval · 5-agent crew · FastAPI + OpenWebUI · Phoenix tracing · guardrails · human-in-the-loop review queue · agent- and model-level fallback · hash-chain audit log · a unified control plane · a first RAGAs pass — 22 passing tests</a:t>
+              <a:t>Ingestion · hybrid retrieval · 5-agent crew · FastAPI + OpenWebUI · Phoenix tracing · guardrails · human-in-the-loop review queue · agent- and model-level fallback · smart bypass · semantic cache · hash-chain audit log · a unified control plane · a first RAGAs pass — 29 passing tests</a:t>
             </a:r>
             <a:endParaRPr lang="en-US" sz="1000" dirty="0"/>
           </a:p>
@@ -4041,15 +4318,15 @@
       </p:sp>
       <p:pic>
         <p:nvPicPr>
-          <p:cNvPr id="9" name="Image 1" descr="Clock"/>
+          <p:cNvPr id="9" name="Image 1" descr="Clock">    </p:cNvPr>
           <p:cNvPicPr>
             <a:picLocks noChangeAspect="1"/>
           </p:cNvPicPr>
           <p:nvPr/>
         </p:nvPicPr>
         <p:blipFill>
-          <a:blip r:embed="rId4"/>
-          <a:srcRect/>
+          <a:blip r:embed="rId2"/>
+          <a:srcRect l="0" r="0" t="0" b="0"/>
           <a:stretch/>
         </p:blipFill>
         <p:spPr>
@@ -4085,7 +4362,7 @@
           </a:bodyPr>
           <a:lstStyle/>
           <a:p>
-            <a:pPr marL="0" indent="0" algn="l">
+            <a:pPr algn="l" indent="0" marL="0">
               <a:lnSpc>
                 <a:spcPts val="1560"/>
               </a:lnSpc>
@@ -4129,7 +4406,7 @@
           </a:bodyPr>
           <a:lstStyle/>
           <a:p>
-            <a:pPr marL="0" indent="0" algn="l">
+            <a:pPr algn="l" indent="0" marL="0">
               <a:lnSpc>
                 <a:spcPts val="1550"/>
               </a:lnSpc>
@@ -4174,15 +4451,15 @@
       </p:sp>
       <p:pic>
         <p:nvPicPr>
-          <p:cNvPr id="13" name="Image 2" descr="Cloud"/>
+          <p:cNvPr id="13" name="Image 2" descr="Cloud">    </p:cNvPr>
           <p:cNvPicPr>
             <a:picLocks noChangeAspect="1"/>
           </p:cNvPicPr>
           <p:nvPr/>
         </p:nvPicPr>
         <p:blipFill>
-          <a:blip r:embed="rId5"/>
-          <a:srcRect/>
+          <a:blip r:embed="rId3"/>
+          <a:srcRect l="0" r="0" t="0" b="0"/>
           <a:stretch/>
         </p:blipFill>
         <p:spPr>
@@ -4218,7 +4495,7 @@
           </a:bodyPr>
           <a:lstStyle/>
           <a:p>
-            <a:pPr marL="0" indent="0" algn="l">
+            <a:pPr algn="l" indent="0" marL="0">
               <a:lnSpc>
                 <a:spcPts val="1560"/>
               </a:lnSpc>
@@ -4262,7 +4539,7 @@
           </a:bodyPr>
           <a:lstStyle/>
           <a:p>
-            <a:pPr marL="0" indent="0" algn="l">
+            <a:pPr algn="l" indent="0" marL="0">
               <a:lnSpc>
                 <a:spcPts val="1550"/>
               </a:lnSpc>
@@ -4306,7 +4583,7 @@
           </a:bodyPr>
           <a:lstStyle/>
           <a:p>
-            <a:pPr marL="0" indent="0" algn="l">
+            <a:pPr algn="l" indent="0" marL="0">
               <a:lnSpc>
                 <a:spcPts val="1680"/>
               </a:lnSpc>
@@ -4350,7 +4627,7 @@
           </a:bodyPr>
           <a:lstStyle/>
           <a:p>
-            <a:pPr marL="0" indent="0" algn="l">
+            <a:pPr algn="l" indent="0" marL="0">
               <a:lnSpc>
                 <a:spcPts val="1680"/>
               </a:lnSpc>
@@ -4365,7 +4642,7 @@
                 <a:ea typeface="IBM Plex Sans" pitchFamily="34" charset="-122"/>
                 <a:cs typeface="IBM Plex Sans" pitchFamily="34" charset="-120"/>
               </a:rPr>
-              <a:t>11 / 14</a:t>
+              <a:t>11 / 15</a:t>
             </a:r>
             <a:endParaRPr lang="en-US" sz="1200" dirty="0"/>
           </a:p>
@@ -4387,7 +4664,6 @@
         <a:solidFill>
           <a:srgbClr val="FBFBF8"/>
         </a:solidFill>
-        <a:effectLst/>
       </p:bgPr>
     </p:bg>
     <p:spTree>
@@ -4427,14 +4703,14 @@
           </a:bodyPr>
           <a:lstStyle/>
           <a:p>
-            <a:pPr marL="0" indent="0" algn="l">
+            <a:pPr algn="l" indent="0" marL="0">
               <a:lnSpc>
                 <a:spcPts val="1680"/>
               </a:lnSpc>
               <a:buNone/>
             </a:pPr>
             <a:r>
-              <a:rPr lang="en-US" sz="1200" b="1" kern="0" spc="150" dirty="0">
+              <a:rPr lang="en-US" sz="1200" b="1" spc="150" kern="0" dirty="0">
                 <a:solidFill>
                   <a:srgbClr val="B08D57"/>
                 </a:solidFill>
@@ -4471,7 +4747,7 @@
           </a:bodyPr>
           <a:lstStyle/>
           <a:p>
-            <a:pPr marL="0" indent="0" algn="l">
+            <a:pPr algn="l" indent="0" marL="0">
               <a:lnSpc>
                 <a:spcPts val="3450"/>
               </a:lnSpc>
@@ -4542,7 +4818,7 @@
           </a:bodyPr>
           <a:lstStyle/>
           <a:p>
-            <a:pPr marL="0" indent="0" algn="l">
+            <a:pPr algn="l" indent="0" marL="0">
               <a:lnSpc>
                 <a:spcPts val="1560"/>
               </a:lnSpc>
@@ -4586,7 +4862,7 @@
           </a:bodyPr>
           <a:lstStyle/>
           <a:p>
-            <a:pPr marL="0" indent="0" algn="l">
+            <a:pPr algn="l" indent="0" marL="0">
               <a:lnSpc>
                 <a:spcPts val="1650"/>
               </a:lnSpc>
@@ -4630,7 +4906,7 @@
           </a:bodyPr>
           <a:lstStyle/>
           <a:p>
-            <a:pPr marL="0" indent="0" algn="l">
+            <a:pPr algn="l" indent="0" marL="0">
               <a:lnSpc>
                 <a:spcPts val="1650"/>
               </a:lnSpc>
@@ -4645,7 +4921,7 @@
                 <a:ea typeface="IBM Plex Sans" pitchFamily="34" charset="-122"/>
                 <a:cs typeface="IBM Plex Sans" pitchFamily="34" charset="-120"/>
               </a:rPr>
-              <a:t>Ollama native on the host — qwen2.5:7b-instruct + nomic-embed-text</a:t>
+              <a:t>Ollama native on the host — llama3.2:3b + nomic-embed-text</a:t>
             </a:r>
             <a:endParaRPr lang="en-US" sz="1100" dirty="0"/>
           </a:p>
@@ -4674,7 +4950,7 @@
           </a:bodyPr>
           <a:lstStyle/>
           <a:p>
-            <a:pPr marL="0" indent="0" algn="l">
+            <a:pPr algn="l" indent="0" marL="0">
               <a:lnSpc>
                 <a:spcPts val="1650"/>
               </a:lnSpc>
@@ -4740,7 +5016,7 @@
           </a:bodyPr>
           <a:lstStyle/>
           <a:p>
-            <a:pPr marL="0" indent="0" algn="l">
+            <a:pPr algn="l" indent="0" marL="0">
               <a:lnSpc>
                 <a:spcPts val="1560"/>
               </a:lnSpc>
@@ -4784,7 +5060,7 @@
           </a:bodyPr>
           <a:lstStyle/>
           <a:p>
-            <a:pPr marL="0" indent="0" algn="l">
+            <a:pPr algn="l" indent="0" marL="0">
               <a:lnSpc>
                 <a:spcPts val="1650"/>
               </a:lnSpc>
@@ -4828,7 +5104,7 @@
           </a:bodyPr>
           <a:lstStyle/>
           <a:p>
-            <a:pPr marL="0" indent="0" algn="l">
+            <a:pPr algn="l" indent="0" marL="0">
               <a:lnSpc>
                 <a:spcPts val="1650"/>
               </a:lnSpc>
@@ -4872,7 +5148,7 @@
           </a:bodyPr>
           <a:lstStyle/>
           <a:p>
-            <a:pPr marL="0" indent="0" algn="l">
+            <a:pPr algn="l" indent="0" marL="0">
               <a:lnSpc>
                 <a:spcPts val="1650"/>
               </a:lnSpc>
@@ -4916,7 +5192,7 @@
           </a:bodyPr>
           <a:lstStyle/>
           <a:p>
-            <a:pPr marL="0" indent="0" algn="l">
+            <a:pPr algn="l" indent="0" marL="0">
               <a:lnSpc>
                 <a:spcPts val="1680"/>
               </a:lnSpc>
@@ -4960,7 +5236,7 @@
           </a:bodyPr>
           <a:lstStyle/>
           <a:p>
-            <a:pPr marL="0" indent="0" algn="l">
+            <a:pPr algn="l" indent="0" marL="0">
               <a:lnSpc>
                 <a:spcPts val="1680"/>
               </a:lnSpc>
@@ -4975,7 +5251,7 @@
                 <a:ea typeface="IBM Plex Sans" pitchFamily="34" charset="-122"/>
                 <a:cs typeface="IBM Plex Sans" pitchFamily="34" charset="-120"/>
               </a:rPr>
-              <a:t>12 / 14</a:t>
+              <a:t>12 / 15</a:t>
             </a:r>
             <a:endParaRPr lang="en-US" sz="1200" dirty="0"/>
           </a:p>
@@ -4997,7 +5273,6 @@
         <a:solidFill>
           <a:srgbClr val="F0EFE9"/>
         </a:solidFill>
-        <a:effectLst/>
       </p:bgPr>
     </p:bg>
     <p:spTree>
@@ -5037,14 +5312,14 @@
           </a:bodyPr>
           <a:lstStyle/>
           <a:p>
-            <a:pPr marL="0" indent="0" algn="l">
+            <a:pPr algn="l" indent="0" marL="0">
               <a:lnSpc>
                 <a:spcPts val="1680"/>
               </a:lnSpc>
               <a:buNone/>
             </a:pPr>
             <a:r>
-              <a:rPr lang="en-US" sz="1200" b="1" kern="0" spc="150" dirty="0">
+              <a:rPr lang="en-US" sz="1200" b="1" spc="150" kern="0" dirty="0">
                 <a:solidFill>
                   <a:srgbClr val="B08D57"/>
                 </a:solidFill>
@@ -5081,7 +5356,7 @@
           </a:bodyPr>
           <a:lstStyle/>
           <a:p>
-            <a:pPr marL="0" indent="0" algn="l">
+            <a:pPr algn="l" indent="0" marL="0">
               <a:lnSpc>
                 <a:spcPts val="3450"/>
               </a:lnSpc>
@@ -5119,7 +5394,7 @@
             </a:avLst>
           </a:prstGeom>
           <a:solidFill>
-            <a:srgbClr val="FFFFFF"/>
+            <a:srgbClr val="1F3A5C"/>
           </a:solidFill>
           <a:ln/>
         </p:spPr>
@@ -5147,7 +5422,7 @@
           </a:bodyPr>
           <a:lstStyle/>
           <a:p>
-            <a:pPr marL="0" indent="0" algn="l">
+            <a:pPr algn="l" indent="0" marL="0">
               <a:lnSpc>
                 <a:spcPts val="1610"/>
               </a:lnSpc>
@@ -5156,13 +5431,13 @@
             <a:r>
               <a:rPr lang="en-US" sz="1150" b="1" dirty="0">
                 <a:solidFill>
-                  <a:srgbClr val="1F3A5C"/>
-                </a:solidFill>
-                <a:latin typeface="IBM Plex Sans" pitchFamily="34" charset="0"/>
-                <a:ea typeface="IBM Plex Sans" pitchFamily="34" charset="-122"/>
-                <a:cs typeface="IBM Plex Sans" pitchFamily="34" charset="-120"/>
-              </a:rPr>
-              <a:t>Document versioning</a:t>
+                  <a:srgbClr val="FBFBF8"/>
+                </a:solidFill>
+                <a:latin typeface="IBM Plex Sans" pitchFamily="34" charset="0"/>
+                <a:ea typeface="IBM Plex Sans" pitchFamily="34" charset="-122"/>
+                <a:cs typeface="IBM Plex Sans" pitchFamily="34" charset="-120"/>
+              </a:rPr>
+              <a:t>Smart bypass</a:t>
             </a:r>
             <a:endParaRPr lang="en-US" sz="1150" dirty="0"/>
           </a:p>
@@ -5177,21 +5452,21 @@
         <p:spPr>
           <a:xfrm>
             <a:off x="965200" y="2329111"/>
-            <a:ext cx="3226613" cy="203200"/>
-          </a:xfrm>
-          <a:prstGeom prst="rect">
-            <a:avLst/>
-          </a:prstGeom>
-          <a:noFill/>
-          <a:ln/>
-        </p:spPr>
-        <p:txBody>
-          <a:bodyPr wrap="square" lIns="0" tIns="0" rIns="0" bIns="0" rtlCol="0" anchor="t">
-            <a:normAutofit/>
-          </a:bodyPr>
-          <a:lstStyle/>
-          <a:p>
-            <a:pPr marL="0" indent="0" algn="l">
+            <a:ext cx="3226613" cy="381000"/>
+          </a:xfrm>
+          <a:prstGeom prst="rect">
+            <a:avLst/>
+          </a:prstGeom>
+          <a:noFill/>
+          <a:ln/>
+        </p:spPr>
+        <p:txBody>
+          <a:bodyPr wrap="square" lIns="0" tIns="0" rIns="0" bIns="0" rtlCol="0" anchor="t">
+            <a:normAutofit/>
+          </a:bodyPr>
+          <a:lstStyle/>
+          <a:p>
+            <a:pPr algn="l" indent="0" marL="0">
               <a:lnSpc>
                 <a:spcPts val="1400"/>
               </a:lnSpc>
@@ -5200,13 +5475,13 @@
             <a:r>
               <a:rPr lang="en-US" sz="1000" dirty="0">
                 <a:solidFill>
-                  <a:srgbClr val="5B6472"/>
-                </a:solidFill>
-                <a:latin typeface="IBM Plex Sans" pitchFamily="34" charset="0"/>
-                <a:ea typeface="IBM Plex Sans" pitchFamily="34" charset="-122"/>
-                <a:cs typeface="IBM Plex Sans" pitchFamily="34" charset="-120"/>
-              </a:rPr>
-              <a:t>active / superseded status, never mixed</a:t>
+                  <a:srgbClr val="D9E1E8"/>
+                </a:solidFill>
+                <a:latin typeface="IBM Plex Sans" pitchFamily="34" charset="0"/>
+                <a:ea typeface="IBM Plex Sans" pitchFamily="34" charset="-122"/>
+                <a:cs typeface="IBM Plex Sans" pitchFamily="34" charset="-120"/>
+              </a:rPr>
+              <a:t>107.8s → 58.3s — regex + cosine similarity skip an LLM call when the signal is already decisive</a:t>
             </a:r>
             <a:endParaRPr lang="en-US" sz="1000" dirty="0"/>
           </a:p>
@@ -5229,7 +5504,7 @@
             </a:avLst>
           </a:prstGeom>
           <a:solidFill>
-            <a:srgbClr val="FFFFFF"/>
+            <a:srgbClr val="1F3A5C"/>
           </a:solidFill>
           <a:ln/>
         </p:spPr>
@@ -5257,7 +5532,7 @@
           </a:bodyPr>
           <a:lstStyle/>
           <a:p>
-            <a:pPr marL="0" indent="0" algn="l">
+            <a:pPr algn="l" indent="0" marL="0">
               <a:lnSpc>
                 <a:spcPts val="1610"/>
               </a:lnSpc>
@@ -5266,13 +5541,13 @@
             <a:r>
               <a:rPr lang="en-US" sz="1150" b="1" dirty="0">
                 <a:solidFill>
-                  <a:srgbClr val="1F3A5C"/>
-                </a:solidFill>
-                <a:latin typeface="IBM Plex Sans" pitchFamily="34" charset="0"/>
-                <a:ea typeface="IBM Plex Sans" pitchFamily="34" charset="-122"/>
-                <a:cs typeface="IBM Plex Sans" pitchFamily="34" charset="-120"/>
-              </a:rPr>
-              <a:t>Checksum dedupe</a:t>
+                  <a:srgbClr val="FBFBF8"/>
+                </a:solidFill>
+                <a:latin typeface="IBM Plex Sans" pitchFamily="34" charset="0"/>
+                <a:ea typeface="IBM Plex Sans" pitchFamily="34" charset="-122"/>
+                <a:cs typeface="IBM Plex Sans" pitchFamily="34" charset="-120"/>
+              </a:rPr>
+              <a:t>Semantic answer cache</a:t>
             </a:r>
             <a:endParaRPr lang="en-US" sz="1150" dirty="0"/>
           </a:p>
@@ -5287,21 +5562,21 @@
         <p:spPr>
           <a:xfrm>
             <a:off x="4529634" y="2329111"/>
-            <a:ext cx="3226664" cy="203200"/>
-          </a:xfrm>
-          <a:prstGeom prst="rect">
-            <a:avLst/>
-          </a:prstGeom>
-          <a:noFill/>
-          <a:ln/>
-        </p:spPr>
-        <p:txBody>
-          <a:bodyPr wrap="square" lIns="0" tIns="0" rIns="0" bIns="0" rtlCol="0" anchor="t">
-            <a:normAutofit/>
-          </a:bodyPr>
-          <a:lstStyle/>
-          <a:p>
-            <a:pPr marL="0" indent="0" algn="l">
+            <a:ext cx="3226664" cy="381000"/>
+          </a:xfrm>
+          <a:prstGeom prst="rect">
+            <a:avLst/>
+          </a:prstGeom>
+          <a:noFill/>
+          <a:ln/>
+        </p:spPr>
+        <p:txBody>
+          <a:bodyPr wrap="square" lIns="0" tIns="0" rIns="0" bIns="0" rtlCol="0" anchor="t">
+            <a:normAutofit/>
+          </a:bodyPr>
+          <a:lstStyle/>
+          <a:p>
+            <a:pPr algn="l" indent="0" marL="0">
               <a:lnSpc>
                 <a:spcPts val="1400"/>
               </a:lnSpc>
@@ -5310,13 +5585,13 @@
             <a:r>
               <a:rPr lang="en-US" sz="1000" dirty="0">
                 <a:solidFill>
-                  <a:srgbClr val="5B6472"/>
-                </a:solidFill>
-                <a:latin typeface="IBM Plex Sans" pitchFamily="34" charset="0"/>
-                <a:ea typeface="IBM Plex Sans" pitchFamily="34" charset="-122"/>
-                <a:cs typeface="IBM Plex Sans" pitchFamily="34" charset="-120"/>
-              </a:rPr>
-              <a:t>re-ingest is a verified no-op</a:t>
+                  <a:srgbClr val="D9E1E8"/>
+                </a:solidFill>
+                <a:latin typeface="IBM Plex Sans" pitchFamily="34" charset="0"/>
+                <a:ea typeface="IBM Plex Sans" pitchFamily="34" charset="-122"/>
+                <a:cs typeface="IBM Plex Sans" pitchFamily="34" charset="-120"/>
+              </a:rPr>
+              <a:t>50.6s → 0.1s on a repeat question — zero LLM calls, same citations</a:t>
             </a:r>
             <a:endParaRPr lang="en-US" sz="1000" dirty="0"/>
           </a:p>
@@ -5367,7 +5642,7 @@
           </a:bodyPr>
           <a:lstStyle/>
           <a:p>
-            <a:pPr marL="0" indent="0" algn="l">
+            <a:pPr algn="l" indent="0" marL="0">
               <a:lnSpc>
                 <a:spcPts val="1610"/>
               </a:lnSpc>
@@ -5411,7 +5686,7 @@
           </a:bodyPr>
           <a:lstStyle/>
           <a:p>
-            <a:pPr marL="0" indent="0" algn="l">
+            <a:pPr algn="l" indent="0" marL="0">
               <a:lnSpc>
                 <a:spcPts val="1400"/>
               </a:lnSpc>
@@ -5477,7 +5752,7 @@
           </a:bodyPr>
           <a:lstStyle/>
           <a:p>
-            <a:pPr marL="0" indent="0" algn="l">
+            <a:pPr algn="l" indent="0" marL="0">
               <a:lnSpc>
                 <a:spcPts val="1610"/>
               </a:lnSpc>
@@ -5521,7 +5796,7 @@
           </a:bodyPr>
           <a:lstStyle/>
           <a:p>
-            <a:pPr marL="0" indent="0" algn="l">
+            <a:pPr algn="l" indent="0" marL="0">
               <a:lnSpc>
                 <a:spcPts val="1400"/>
               </a:lnSpc>
@@ -5587,7 +5862,7 @@
           </a:bodyPr>
           <a:lstStyle/>
           <a:p>
-            <a:pPr marL="0" indent="0" algn="l">
+            <a:pPr algn="l" indent="0" marL="0">
               <a:lnSpc>
                 <a:spcPts val="1610"/>
               </a:lnSpc>
@@ -5602,7 +5877,7 @@
                 <a:ea typeface="IBM Plex Sans" pitchFamily="34" charset="-122"/>
                 <a:cs typeface="IBM Plex Sans" pitchFamily="34" charset="-120"/>
               </a:rPr>
-              <a:t>RAG error taxonomy</a:t>
+              <a:t>Checksum dedupe</a:t>
             </a:r>
             <a:endParaRPr lang="en-US" sz="1150" dirty="0"/>
           </a:p>
@@ -5631,7 +5906,7 @@
           </a:bodyPr>
           <a:lstStyle/>
           <a:p>
-            <a:pPr marL="0" indent="0" algn="l">
+            <a:pPr algn="l" indent="0" marL="0">
               <a:lnSpc>
                 <a:spcPts val="1400"/>
               </a:lnSpc>
@@ -5646,7 +5921,7 @@
                 <a:ea typeface="IBM Plex Sans" pitchFamily="34" charset="-122"/>
                 <a:cs typeface="IBM Plex Sans" pitchFamily="34" charset="-120"/>
               </a:rPr>
-              <a:t>structures the feedback loop, not just "improve"</a:t>
+              <a:t>re-ingest is a verified no-op</a:t>
             </a:r>
             <a:endParaRPr lang="en-US" sz="1000" dirty="0"/>
           </a:p>
@@ -5697,7 +5972,7 @@
           </a:bodyPr>
           <a:lstStyle/>
           <a:p>
-            <a:pPr marL="0" indent="0" algn="l">
+            <a:pPr algn="l" indent="0" marL="0">
               <a:lnSpc>
                 <a:spcPts val="1610"/>
               </a:lnSpc>
@@ -5741,7 +6016,7 @@
           </a:bodyPr>
           <a:lstStyle/>
           <a:p>
-            <a:pPr marL="0" indent="0" algn="l">
+            <a:pPr algn="l" indent="0" marL="0">
               <a:lnSpc>
                 <a:spcPts val="1400"/>
               </a:lnSpc>
@@ -5785,7 +6060,7 @@
           </a:bodyPr>
           <a:lstStyle/>
           <a:p>
-            <a:pPr marL="0" indent="0" algn="l">
+            <a:pPr algn="l" indent="0" marL="0">
               <a:lnSpc>
                 <a:spcPts val="1680"/>
               </a:lnSpc>
@@ -5829,7 +6104,7 @@
           </a:bodyPr>
           <a:lstStyle/>
           <a:p>
-            <a:pPr marL="0" indent="0" algn="l">
+            <a:pPr algn="l" indent="0" marL="0">
               <a:lnSpc>
                 <a:spcPts val="1680"/>
               </a:lnSpc>
@@ -5844,7 +6119,7 @@
                 <a:ea typeface="IBM Plex Sans" pitchFamily="34" charset="-122"/>
                 <a:cs typeface="IBM Plex Sans" pitchFamily="34" charset="-120"/>
               </a:rPr>
-              <a:t>13 / 14</a:t>
+              <a:t>13 / 15</a:t>
             </a:r>
             <a:endParaRPr lang="en-US" sz="1200" dirty="0"/>
           </a:p>
@@ -5864,9 +6139,8 @@
     <p:bg>
       <p:bgPr>
         <a:solidFill>
-          <a:srgbClr val="1A2333"/>
+          <a:srgbClr val="F0EFE9"/>
         </a:solidFill>
-        <a:effectLst/>
       </p:bgPr>
     </p:bg>
     <p:spTree>
@@ -5906,14 +6180,662 @@
           </a:bodyPr>
           <a:lstStyle/>
           <a:p>
-            <a:pPr marL="0" indent="0" algn="l">
+            <a:pPr algn="l" indent="0" marL="0">
               <a:lnSpc>
                 <a:spcPts val="1680"/>
               </a:lnSpc>
               <a:buNone/>
             </a:pPr>
             <a:r>
-              <a:rPr lang="en-US" sz="1200" b="1" kern="0" spc="150" dirty="0">
+              <a:rPr lang="en-US" sz="1200" b="1" spc="150" kern="0" dirty="0">
+                <a:solidFill>
+                  <a:srgbClr val="B08D57"/>
+                </a:solidFill>
+                <a:latin typeface="IBM Plex Sans" pitchFamily="34" charset="0"/>
+                <a:ea typeface="IBM Plex Sans" pitchFamily="34" charset="-122"/>
+                <a:cs typeface="IBM Plex Sans" pitchFamily="34" charset="-120"/>
+              </a:rPr>
+              <a:t>ALTERNATIVES CONSIDERED</a:t>
+            </a:r>
+            <a:endParaRPr lang="en-US" sz="1200" dirty="0"/>
+          </a:p>
+        </p:txBody>
+      </p:sp>
+      <p:sp>
+        <p:nvSpPr>
+          <p:cNvPr id="3" name="Text 1"/>
+          <p:cNvSpPr/>
+          <p:nvPr/>
+        </p:nvSpPr>
+        <p:spPr>
+          <a:xfrm>
+            <a:off x="812800" y="1229320"/>
+            <a:ext cx="10883392" cy="405110"/>
+          </a:xfrm>
+          <a:prstGeom prst="rect">
+            <a:avLst/>
+          </a:prstGeom>
+          <a:noFill/>
+          <a:ln/>
+        </p:spPr>
+        <p:txBody>
+          <a:bodyPr wrap="square" lIns="0" tIns="0" rIns="0" bIns="0" rtlCol="0" anchor="t">
+            <a:normAutofit/>
+          </a:bodyPr>
+          <a:lstStyle/>
+          <a:p>
+            <a:pPr algn="l" indent="0" marL="0">
+              <a:lnSpc>
+                <a:spcPts val="2990"/>
+              </a:lnSpc>
+              <a:buNone/>
+            </a:pPr>
+            <a:r>
+              <a:rPr lang="en-US" sz="2600" b="1" dirty="0">
+                <a:solidFill>
+                  <a:srgbClr val="1A2333"/>
+                </a:solidFill>
+                <a:latin typeface="EB Garamond" pitchFamily="34" charset="0"/>
+                <a:ea typeface="EB Garamond" pitchFamily="34" charset="-122"/>
+                <a:cs typeface="EB Garamond" pitchFamily="34" charset="-120"/>
+              </a:rPr>
+              <a:t>CrewAI + Phoenix, not LangGraph + LangSmith — and why</a:t>
+            </a:r>
+            <a:endParaRPr lang="en-US" sz="2600" dirty="0"/>
+          </a:p>
+        </p:txBody>
+      </p:sp>
+      <p:sp>
+        <p:nvSpPr>
+          <p:cNvPr id="4" name="Shape 2"/>
+          <p:cNvSpPr/>
+          <p:nvPr/>
+        </p:nvSpPr>
+        <p:spPr>
+          <a:xfrm>
+            <a:off x="812800" y="1812230"/>
+            <a:ext cx="5181600" cy="2902049"/>
+          </a:xfrm>
+          <a:prstGeom prst="roundRect">
+            <a:avLst>
+              <a:gd name="adj" fmla="val 3501"/>
+            </a:avLst>
+          </a:prstGeom>
+          <a:solidFill>
+            <a:srgbClr val="FFFFFF"/>
+          </a:solidFill>
+          <a:ln/>
+        </p:spPr>
+      </p:sp>
+      <p:sp>
+        <p:nvSpPr>
+          <p:cNvPr id="5" name="Text 3"/>
+          <p:cNvSpPr/>
+          <p:nvPr/>
+        </p:nvSpPr>
+        <p:spPr>
+          <a:xfrm>
+            <a:off x="1028700" y="2028130"/>
+            <a:ext cx="4892294" cy="215900"/>
+          </a:xfrm>
+          <a:prstGeom prst="rect">
+            <a:avLst/>
+          </a:prstGeom>
+          <a:noFill/>
+          <a:ln/>
+        </p:spPr>
+        <p:txBody>
+          <a:bodyPr wrap="square" lIns="0" tIns="0" rIns="0" bIns="0" rtlCol="0" anchor="t">
+            <a:normAutofit/>
+          </a:bodyPr>
+          <a:lstStyle/>
+          <a:p>
+            <a:pPr algn="l" indent="0" marL="0">
+              <a:lnSpc>
+                <a:spcPts val="1500"/>
+              </a:lnSpc>
+              <a:buNone/>
+            </a:pPr>
+            <a:r>
+              <a:rPr lang="en-US" sz="1250" b="1" dirty="0">
+                <a:solidFill>
+                  <a:srgbClr val="1F3A5C"/>
+                </a:solidFill>
+                <a:latin typeface="IBM Plex Sans" pitchFamily="34" charset="0"/>
+                <a:ea typeface="IBM Plex Sans" pitchFamily="34" charset="-122"/>
+                <a:cs typeface="IBM Plex Sans" pitchFamily="34" charset="-120"/>
+              </a:rPr>
+              <a:t>Orchestration: LangGraph would fit better</a:t>
+            </a:r>
+            <a:endParaRPr lang="en-US" sz="1250" dirty="0"/>
+          </a:p>
+        </p:txBody>
+      </p:sp>
+      <p:sp>
+        <p:nvSpPr>
+          <p:cNvPr id="6" name="Text 4"/>
+          <p:cNvSpPr/>
+          <p:nvPr/>
+        </p:nvSpPr>
+        <p:spPr>
+          <a:xfrm>
+            <a:off x="1028700" y="2307530"/>
+            <a:ext cx="4892294" cy="773311"/>
+          </a:xfrm>
+          <a:prstGeom prst="rect">
+            <a:avLst/>
+          </a:prstGeom>
+          <a:noFill/>
+          <a:ln/>
+        </p:spPr>
+        <p:txBody>
+          <a:bodyPr wrap="square" lIns="0" tIns="0" rIns="0" bIns="0" rtlCol="0" anchor="t">
+            <a:normAutofit/>
+          </a:bodyPr>
+          <a:lstStyle/>
+          <a:p>
+            <a:pPr algn="l" indent="0" marL="0">
+              <a:lnSpc>
+                <a:spcPts val="1473"/>
+              </a:lnSpc>
+              <a:buNone/>
+            </a:pPr>
+            <a:r>
+              <a:rPr lang="en-US" sz="950" dirty="0">
+                <a:solidFill>
+                  <a:srgbClr val="5B6472"/>
+                </a:solidFill>
+                <a:latin typeface="IBM Plex Sans" pitchFamily="34" charset="0"/>
+                <a:ea typeface="IBM Plex Sans" pitchFamily="34" charset="-122"/>
+                <a:cs typeface="IBM Plex Sans" pitchFamily="34" charset="-120"/>
+              </a:rPr>
+              <a:t>Our flow — plan → retrieve → validate → refine/retry → synthesize → cite — is a state machine: explicit state, conditional routing, retry loops, fallback and HITL gates. LangGraph models all of that natively; CrewAI's model is role/task collaboration, with state as a secondary concern.</a:t>
+            </a:r>
+            <a:endParaRPr lang="en-US" sz="950" dirty="0"/>
+          </a:p>
+        </p:txBody>
+      </p:sp>
+      <p:sp>
+        <p:nvSpPr>
+          <p:cNvPr id="7" name="Text 5"/>
+          <p:cNvSpPr/>
+          <p:nvPr/>
+        </p:nvSpPr>
+        <p:spPr>
+          <a:xfrm>
+            <a:off x="1028700" y="3144341"/>
+            <a:ext cx="4892294" cy="960289"/>
+          </a:xfrm>
+          <a:prstGeom prst="rect">
+            <a:avLst/>
+          </a:prstGeom>
+          <a:noFill/>
+          <a:ln/>
+        </p:spPr>
+        <p:txBody>
+          <a:bodyPr wrap="square" lIns="0" tIns="0" rIns="0" bIns="0" rtlCol="0" anchor="t">
+            <a:normAutofit/>
+          </a:bodyPr>
+          <a:lstStyle/>
+          <a:p>
+            <a:pPr algn="l" indent="0" marL="0">
+              <a:lnSpc>
+                <a:spcPts val="1473"/>
+              </a:lnSpc>
+              <a:buNone/>
+            </a:pPr>
+            <a:r>
+              <a:rPr lang="en-US" sz="950" dirty="0">
+                <a:solidFill>
+                  <a:srgbClr val="5B6472"/>
+                </a:solidFill>
+                <a:latin typeface="IBM Plex Sans" pitchFamily="34" charset="0"/>
+                <a:ea typeface="IBM Plex Sans" pitchFamily="34" charset="-122"/>
+                <a:cs typeface="IBM Plex Sans" pitchFamily="34" charset="-120"/>
+              </a:rPr>
+              <a:t>The assessment mandates CrewAI, so I didn't add LangGraph on top of it — CrewAI + LangGraph + LlamaIndex would be three orchestration-adjacent frameworks for one flow, a harder question to defend than the gap it fills. What LangGraph gives for free, </a:t>
+            </a:r>
+            <a:r>
+              <a:rPr lang="en-US" sz="950" b="1" dirty="0">
+                <a:solidFill>
+                  <a:srgbClr val="5B6472"/>
+                </a:solidFill>
+                <a:latin typeface="IBM Plex Sans" pitchFamily="34" charset="0"/>
+                <a:ea typeface="IBM Plex Sans" pitchFamily="34" charset="-122"/>
+                <a:cs typeface="IBM Plex Sans" pitchFamily="34" charset="-120"/>
+              </a:rPr>
+              <a:t>orchestrator.py</a:t>
+            </a:r>
+            <a:r>
+              <a:rPr lang="en-US" sz="950" dirty="0">
+                <a:solidFill>
+                  <a:srgbClr val="5B6472"/>
+                </a:solidFill>
+                <a:latin typeface="IBM Plex Sans" pitchFamily="34" charset="0"/>
+                <a:ea typeface="IBM Plex Sans" pitchFamily="34" charset="-122"/>
+                <a:cs typeface="IBM Plex Sans" pitchFamily="34" charset="-120"/>
+              </a:rPr>
+              <a:t> implements explicitly instead: state, retries, validation gates, abstention, escalation.</a:t>
+            </a:r>
+            <a:endParaRPr lang="en-US" sz="950" dirty="0"/>
+          </a:p>
+        </p:txBody>
+      </p:sp>
+      <p:sp>
+        <p:nvSpPr>
+          <p:cNvPr id="8" name="Shape 6"/>
+          <p:cNvSpPr/>
+          <p:nvPr/>
+        </p:nvSpPr>
+        <p:spPr>
+          <a:xfrm>
+            <a:off x="6197600" y="1812230"/>
+            <a:ext cx="5181600" cy="2902049"/>
+          </a:xfrm>
+          <a:prstGeom prst="roundRect">
+            <a:avLst>
+              <a:gd name="adj" fmla="val 3501"/>
+            </a:avLst>
+          </a:prstGeom>
+          <a:solidFill>
+            <a:srgbClr val="FFFFFF"/>
+          </a:solidFill>
+          <a:ln/>
+        </p:spPr>
+      </p:sp>
+      <p:sp>
+        <p:nvSpPr>
+          <p:cNvPr id="9" name="Text 7"/>
+          <p:cNvSpPr/>
+          <p:nvPr/>
+        </p:nvSpPr>
+        <p:spPr>
+          <a:xfrm>
+            <a:off x="6413500" y="2028130"/>
+            <a:ext cx="4892294" cy="215900"/>
+          </a:xfrm>
+          <a:prstGeom prst="rect">
+            <a:avLst/>
+          </a:prstGeom>
+          <a:noFill/>
+          <a:ln/>
+        </p:spPr>
+        <p:txBody>
+          <a:bodyPr wrap="square" lIns="0" tIns="0" rIns="0" bIns="0" rtlCol="0" anchor="t">
+            <a:normAutofit/>
+          </a:bodyPr>
+          <a:lstStyle/>
+          <a:p>
+            <a:pPr algn="l" indent="0" marL="0">
+              <a:lnSpc>
+                <a:spcPts val="1500"/>
+              </a:lnSpc>
+              <a:buNone/>
+            </a:pPr>
+            <a:r>
+              <a:rPr lang="en-US" sz="1250" b="1" dirty="0">
+                <a:solidFill>
+                  <a:srgbClr val="1F3A5C"/>
+                </a:solidFill>
+                <a:latin typeface="IBM Plex Sans" pitchFamily="34" charset="0"/>
+                <a:ea typeface="IBM Plex Sans" pitchFamily="34" charset="-122"/>
+                <a:cs typeface="IBM Plex Sans" pitchFamily="34" charset="-120"/>
+              </a:rPr>
+              <a:t>Observability: LangSmith could be a better fit</a:t>
+            </a:r>
+            <a:endParaRPr lang="en-US" sz="1250" dirty="0"/>
+          </a:p>
+        </p:txBody>
+      </p:sp>
+      <p:sp>
+        <p:nvSpPr>
+          <p:cNvPr id="10" name="Text 8"/>
+          <p:cNvSpPr/>
+          <p:nvPr/>
+        </p:nvSpPr>
+        <p:spPr>
+          <a:xfrm>
+            <a:off x="6413500" y="2307530"/>
+            <a:ext cx="4892294" cy="773311"/>
+          </a:xfrm>
+          <a:prstGeom prst="rect">
+            <a:avLst/>
+          </a:prstGeom>
+          <a:noFill/>
+          <a:ln/>
+        </p:spPr>
+        <p:txBody>
+          <a:bodyPr wrap="square" lIns="0" tIns="0" rIns="0" bIns="0" rtlCol="0" anchor="t">
+            <a:normAutofit/>
+          </a:bodyPr>
+          <a:lstStyle/>
+          <a:p>
+            <a:pPr algn="l" indent="0" marL="0">
+              <a:lnSpc>
+                <a:spcPts val="1473"/>
+              </a:lnSpc>
+              <a:buNone/>
+            </a:pPr>
+            <a:r>
+              <a:rPr lang="en-US" sz="950" dirty="0">
+                <a:solidFill>
+                  <a:srgbClr val="5B6472"/>
+                </a:solidFill>
+                <a:latin typeface="IBM Plex Sans" pitchFamily="34" charset="0"/>
+                <a:ea typeface="IBM Plex Sans" pitchFamily="34" charset="-122"/>
+                <a:cs typeface="IBM Plex Sans" pitchFamily="34" charset="-120"/>
+              </a:rPr>
+              <a:t>LangSmith has deeper native tracing for LangChain/LangGraph pipelines specifically, plus a more polished built-in dataset/eval workflow. Phoenix was chosen for this build because it's open-source, self-hostable, and OTel-native — no external account, no data leaving the laptop.</a:t>
+            </a:r>
+            <a:endParaRPr lang="en-US" sz="950" dirty="0"/>
+          </a:p>
+        </p:txBody>
+      </p:sp>
+      <p:sp>
+        <p:nvSpPr>
+          <p:cNvPr id="11" name="Text 9"/>
+          <p:cNvSpPr/>
+          <p:nvPr/>
+        </p:nvSpPr>
+        <p:spPr>
+          <a:xfrm>
+            <a:off x="6413500" y="3144341"/>
+            <a:ext cx="4892294" cy="586333"/>
+          </a:xfrm>
+          <a:prstGeom prst="rect">
+            <a:avLst/>
+          </a:prstGeom>
+          <a:noFill/>
+          <a:ln/>
+        </p:spPr>
+        <p:txBody>
+          <a:bodyPr wrap="square" lIns="0" tIns="0" rIns="0" bIns="0" rtlCol="0" anchor="t">
+            <a:normAutofit/>
+          </a:bodyPr>
+          <a:lstStyle/>
+          <a:p>
+            <a:pPr algn="l" indent="0" marL="0">
+              <a:lnSpc>
+                <a:spcPts val="1473"/>
+              </a:lnSpc>
+              <a:buNone/>
+            </a:pPr>
+            <a:r>
+              <a:rPr lang="en-US" sz="950" dirty="0">
+                <a:solidFill>
+                  <a:srgbClr val="5B6472"/>
+                </a:solidFill>
+                <a:latin typeface="IBM Plex Sans" pitchFamily="34" charset="0"/>
+                <a:ea typeface="IBM Plex Sans" pitchFamily="34" charset="-122"/>
+                <a:cs typeface="IBM Plex Sans" pitchFamily="34" charset="-120"/>
+              </a:rPr>
+              <a:t>That fits a fully local, single-machine deployment. On a LangGraph-based stack, or a team already invested in LangSmith, the tradeoff inverts — it isn't a claim that Phoenix is better in general, only that it fit this project's constraints.</a:t>
+            </a:r>
+            <a:endParaRPr lang="en-US" sz="950" dirty="0"/>
+          </a:p>
+        </p:txBody>
+      </p:sp>
+      <p:sp>
+        <p:nvSpPr>
+          <p:cNvPr id="12" name="Shape 10"/>
+          <p:cNvSpPr/>
+          <p:nvPr/>
+        </p:nvSpPr>
+        <p:spPr>
+          <a:xfrm>
+            <a:off x="812800" y="4917480"/>
+            <a:ext cx="10566400" cy="924520"/>
+          </a:xfrm>
+          <a:prstGeom prst="roundRect">
+            <a:avLst>
+              <a:gd name="adj" fmla="val 10989"/>
+            </a:avLst>
+          </a:prstGeom>
+          <a:solidFill>
+            <a:srgbClr val="1F3A5C"/>
+          </a:solidFill>
+          <a:ln/>
+        </p:spPr>
+      </p:sp>
+      <p:sp>
+        <p:nvSpPr>
+          <p:cNvPr id="13" name="Text 11"/>
+          <p:cNvSpPr/>
+          <p:nvPr/>
+        </p:nvSpPr>
+        <p:spPr>
+          <a:xfrm>
+            <a:off x="1028700" y="5095280"/>
+            <a:ext cx="1020366" cy="594320"/>
+          </a:xfrm>
+          <a:prstGeom prst="rect">
+            <a:avLst/>
+          </a:prstGeom>
+          <a:noFill/>
+          <a:ln/>
+        </p:spPr>
+        <p:txBody>
+          <a:bodyPr wrap="square" lIns="0" tIns="0" rIns="0" bIns="0" rtlCol="0" anchor="t">
+            <a:normAutofit/>
+          </a:bodyPr>
+          <a:lstStyle/>
+          <a:p>
+            <a:pPr algn="l" indent="0" marL="0">
+              <a:lnSpc>
+                <a:spcPts val="2240"/>
+              </a:lnSpc>
+              <a:buNone/>
+            </a:pPr>
+            <a:r>
+              <a:rPr lang="en-US" sz="1600" dirty="0">
+                <a:solidFill>
+                  <a:srgbClr val="C9A86A"/>
+                </a:solidFill>
+                <a:latin typeface="Arial" pitchFamily="34" charset="0"/>
+                <a:ea typeface="Arial" pitchFamily="34" charset="-122"/>
+                <a:cs typeface="Arial" pitchFamily="34" charset="-120"/>
+              </a:rPr>
+              <a:t>[icon: Scale]</a:t>
+            </a:r>
+            <a:endParaRPr lang="en-US" sz="1600" dirty="0"/>
+          </a:p>
+        </p:txBody>
+      </p:sp>
+      <p:sp>
+        <p:nvSpPr>
+          <p:cNvPr id="14" name="Text 12"/>
+          <p:cNvSpPr/>
+          <p:nvPr/>
+        </p:nvSpPr>
+        <p:spPr>
+          <a:xfrm>
+            <a:off x="2099866" y="5179715"/>
+            <a:ext cx="9335337" cy="425450"/>
+          </a:xfrm>
+          <a:prstGeom prst="rect">
+            <a:avLst/>
+          </a:prstGeom>
+          <a:noFill/>
+          <a:ln/>
+        </p:spPr>
+        <p:txBody>
+          <a:bodyPr wrap="square" lIns="0" tIns="0" rIns="0" bIns="0" rtlCol="0" anchor="t">
+            <a:normAutofit/>
+          </a:bodyPr>
+          <a:lstStyle/>
+          <a:p>
+            <a:pPr algn="l" indent="0" marL="0">
+              <a:lnSpc>
+                <a:spcPts val="1575"/>
+              </a:lnSpc>
+              <a:buNone/>
+            </a:pPr>
+            <a:r>
+              <a:rPr lang="en-US" sz="1050" dirty="0">
+                <a:solidFill>
+                  <a:srgbClr val="FBFBF8"/>
+                </a:solidFill>
+                <a:latin typeface="IBM Plex Sans" pitchFamily="34" charset="0"/>
+                <a:ea typeface="IBM Plex Sans" pitchFamily="34" charset="-122"/>
+                <a:cs typeface="IBM Plex Sans" pitchFamily="34" charset="-120"/>
+              </a:rPr>
+              <a:t>Fewer frameworks with explicit, auditable control flow beats stacking frameworks to look sophisticated — the same principle behind every other build choice in this deck.</a:t>
+            </a:r>
+            <a:endParaRPr lang="en-US" sz="1050" dirty="0"/>
+          </a:p>
+        </p:txBody>
+      </p:sp>
+      <p:sp>
+        <p:nvSpPr>
+          <p:cNvPr id="15" name="Text 13"/>
+          <p:cNvSpPr/>
+          <p:nvPr/>
+        </p:nvSpPr>
+        <p:spPr>
+          <a:xfrm>
+            <a:off x="812800" y="6238280"/>
+            <a:ext cx="723801" cy="238720"/>
+          </a:xfrm>
+          <a:prstGeom prst="rect">
+            <a:avLst/>
+          </a:prstGeom>
+          <a:noFill/>
+          <a:ln/>
+        </p:spPr>
+        <p:txBody>
+          <a:bodyPr wrap="square" lIns="0" tIns="0" rIns="0" bIns="0" rtlCol="0" anchor="t">
+            <a:normAutofit/>
+          </a:bodyPr>
+          <a:lstStyle/>
+          <a:p>
+            <a:pPr algn="l" indent="0" marL="0">
+              <a:lnSpc>
+                <a:spcPts val="1680"/>
+              </a:lnSpc>
+              <a:buNone/>
+            </a:pPr>
+            <a:r>
+              <a:rPr lang="en-US" sz="1200" dirty="0">
+                <a:solidFill>
+                  <a:srgbClr val="8A8F98"/>
+                </a:solidFill>
+                <a:latin typeface="IBM Plex Sans" pitchFamily="34" charset="0"/>
+                <a:ea typeface="IBM Plex Sans" pitchFamily="34" charset="-122"/>
+                <a:cs typeface="IBM Plex Sans" pitchFamily="34" charset="-120"/>
+              </a:rPr>
+              <a:t>AegisRAG</a:t>
+            </a:r>
+            <a:endParaRPr lang="en-US" sz="1200" dirty="0"/>
+          </a:p>
+        </p:txBody>
+      </p:sp>
+      <p:sp>
+        <p:nvSpPr>
+          <p:cNvPr id="16" name="Text 14"/>
+          <p:cNvSpPr/>
+          <p:nvPr/>
+        </p:nvSpPr>
+        <p:spPr>
+          <a:xfrm>
+            <a:off x="10883106" y="6238280"/>
+            <a:ext cx="546894" cy="238720"/>
+          </a:xfrm>
+          <a:prstGeom prst="rect">
+            <a:avLst/>
+          </a:prstGeom>
+          <a:noFill/>
+          <a:ln/>
+        </p:spPr>
+        <p:txBody>
+          <a:bodyPr wrap="square" lIns="0" tIns="0" rIns="0" bIns="0" rtlCol="0" anchor="t">
+            <a:normAutofit/>
+          </a:bodyPr>
+          <a:lstStyle/>
+          <a:p>
+            <a:pPr algn="l" indent="0" marL="0">
+              <a:lnSpc>
+                <a:spcPts val="1680"/>
+              </a:lnSpc>
+              <a:buNone/>
+            </a:pPr>
+            <a:r>
+              <a:rPr lang="en-US" sz="1200" dirty="0">
+                <a:solidFill>
+                  <a:srgbClr val="8A8F98"/>
+                </a:solidFill>
+                <a:latin typeface="IBM Plex Sans" pitchFamily="34" charset="0"/>
+                <a:ea typeface="IBM Plex Sans" pitchFamily="34" charset="-122"/>
+                <a:cs typeface="IBM Plex Sans" pitchFamily="34" charset="-120"/>
+              </a:rPr>
+              <a:t>14 / 15</a:t>
+            </a:r>
+            <a:endParaRPr lang="en-US" sz="1200" dirty="0"/>
+          </a:p>
+        </p:txBody>
+      </p:sp>
+    </p:spTree>
+  </p:cSld>
+  <p:clrMapOvr>
+    <a:masterClrMapping/>
+  </p:clrMapOvr>
+</p:sld>
+</file>
+
+<file path=ppt/slides/slide15.xml><?xml version="1.0" encoding="utf-8"?>
+<p:sld xmlns:a="http://schemas.openxmlformats.org/drawingml/2006/main" xmlns:r="http://schemas.openxmlformats.org/officeDocument/2006/relationships" xmlns:p="http://schemas.openxmlformats.org/presentationml/2006/main">
+  <p:cSld name="Slide 15">
+    <p:bg>
+      <p:bgPr>
+        <a:solidFill>
+          <a:srgbClr val="1A2333"/>
+        </a:solidFill>
+      </p:bgPr>
+    </p:bg>
+    <p:spTree>
+      <p:nvGrpSpPr>
+        <p:cNvPr id="1" name=""/>
+        <p:cNvGrpSpPr/>
+        <p:nvPr/>
+      </p:nvGrpSpPr>
+      <p:grpSpPr>
+        <a:xfrm>
+          <a:off x="0" y="0"/>
+          <a:ext cx="0" cy="0"/>
+          <a:chOff x="0" y="0"/>
+          <a:chExt cx="0" cy="0"/>
+        </a:xfrm>
+      </p:grpSpPr>
+      <p:sp>
+        <p:nvSpPr>
+          <p:cNvPr id="2" name="Text 0"/>
+          <p:cNvSpPr/>
+          <p:nvPr/>
+        </p:nvSpPr>
+        <p:spPr>
+          <a:xfrm>
+            <a:off x="812800" y="812800"/>
+            <a:ext cx="10883392" cy="238720"/>
+          </a:xfrm>
+          <a:prstGeom prst="rect">
+            <a:avLst/>
+          </a:prstGeom>
+          <a:noFill/>
+          <a:ln/>
+        </p:spPr>
+        <p:txBody>
+          <a:bodyPr wrap="square" lIns="0" tIns="0" rIns="0" bIns="0" rtlCol="0" anchor="t">
+            <a:normAutofit/>
+          </a:bodyPr>
+          <a:lstStyle/>
+          <a:p>
+            <a:pPr algn="l" indent="0" marL="0">
+              <a:lnSpc>
+                <a:spcPts val="1680"/>
+              </a:lnSpc>
+              <a:buNone/>
+            </a:pPr>
+            <a:r>
+              <a:rPr lang="en-US" sz="1200" b="1" spc="150" kern="0" dirty="0">
                 <a:solidFill>
                   <a:srgbClr val="C9A86A"/>
                 </a:solidFill>
@@ -5950,7 +6872,7 @@
           </a:bodyPr>
           <a:lstStyle/>
           <a:p>
-            <a:pPr marL="0" indent="0" algn="l">
+            <a:pPr algn="l" indent="0" marL="0">
               <a:lnSpc>
                 <a:spcPts val="3450"/>
               </a:lnSpc>
@@ -6016,7 +6938,7 @@
           </a:bodyPr>
           <a:lstStyle/>
           <a:p>
-            <a:pPr marL="0" indent="0" algn="l">
+            <a:pPr algn="l" indent="0" marL="0">
               <a:lnSpc>
                 <a:spcPts val="1540"/>
               </a:lnSpc>
@@ -6060,7 +6982,7 @@
           </a:bodyPr>
           <a:lstStyle/>
           <a:p>
-            <a:pPr marL="0" indent="0" algn="l">
+            <a:pPr algn="l" indent="0" marL="0">
               <a:lnSpc>
                 <a:spcPts val="1575"/>
               </a:lnSpc>
@@ -6126,7 +7048,7 @@
           </a:bodyPr>
           <a:lstStyle/>
           <a:p>
-            <a:pPr marL="0" indent="0" algn="l">
+            <a:pPr algn="l" indent="0" marL="0">
               <a:lnSpc>
                 <a:spcPts val="1540"/>
               </a:lnSpc>
@@ -6170,7 +7092,7 @@
           </a:bodyPr>
           <a:lstStyle/>
           <a:p>
-            <a:pPr marL="0" indent="0" algn="l">
+            <a:pPr algn="l" indent="0" marL="0">
               <a:lnSpc>
                 <a:spcPts val="1575"/>
               </a:lnSpc>
@@ -6236,7 +7158,7 @@
           </a:bodyPr>
           <a:lstStyle/>
           <a:p>
-            <a:pPr marL="0" indent="0" algn="l">
+            <a:pPr algn="l" indent="0" marL="0">
               <a:lnSpc>
                 <a:spcPts val="1540"/>
               </a:lnSpc>
@@ -6280,7 +7202,7 @@
           </a:bodyPr>
           <a:lstStyle/>
           <a:p>
-            <a:pPr marL="0" indent="0" algn="l">
+            <a:pPr algn="l" indent="0" marL="0">
               <a:lnSpc>
                 <a:spcPts val="1575"/>
               </a:lnSpc>
@@ -6324,7 +7246,7 @@
           </a:bodyPr>
           <a:lstStyle/>
           <a:p>
-            <a:pPr marL="0" indent="0" algn="l">
+            <a:pPr algn="l" indent="0" marL="0">
               <a:lnSpc>
                 <a:spcPts val="1680"/>
               </a:lnSpc>
@@ -6368,7 +7290,7 @@
           </a:bodyPr>
           <a:lstStyle/>
           <a:p>
-            <a:pPr marL="0" indent="0" algn="l">
+            <a:pPr algn="l" indent="0" marL="0">
               <a:lnSpc>
                 <a:spcPts val="1470"/>
               </a:lnSpc>
@@ -6405,7 +7327,6 @@
         <a:solidFill>
           <a:srgbClr val="FBFBF8"/>
         </a:solidFill>
-        <a:effectLst/>
       </p:bgPr>
     </p:bg>
     <p:spTree>
@@ -6445,14 +7366,14 @@
           </a:bodyPr>
           <a:lstStyle/>
           <a:p>
-            <a:pPr marL="0" indent="0" algn="l">
+            <a:pPr algn="l" indent="0" marL="0">
               <a:lnSpc>
                 <a:spcPts val="1680"/>
               </a:lnSpc>
               <a:buNone/>
             </a:pPr>
             <a:r>
-              <a:rPr lang="en-US" sz="1200" b="1" kern="0" spc="150" dirty="0">
+              <a:rPr lang="en-US" sz="1200" b="1" spc="150" kern="0" dirty="0">
                 <a:solidFill>
                   <a:srgbClr val="B08D57"/>
                 </a:solidFill>
@@ -6489,7 +7410,7 @@
           </a:bodyPr>
           <a:lstStyle/>
           <a:p>
-            <a:pPr marL="0" indent="0" algn="l">
+            <a:pPr algn="l" indent="0" marL="0">
               <a:lnSpc>
                 <a:spcPts val="3450"/>
               </a:lnSpc>
@@ -6560,7 +7481,7 @@
           </a:bodyPr>
           <a:lstStyle/>
           <a:p>
-            <a:pPr marL="0" indent="0" algn="l">
+            <a:pPr algn="l" indent="0" marL="0">
               <a:lnSpc>
                 <a:spcPts val="1680"/>
               </a:lnSpc>
@@ -6604,7 +7525,7 @@
           </a:bodyPr>
           <a:lstStyle/>
           <a:p>
-            <a:pPr marL="0" indent="0" algn="l">
+            <a:pPr algn="l" indent="0" marL="0">
               <a:lnSpc>
                 <a:spcPts val="1725"/>
               </a:lnSpc>
@@ -6670,7 +7591,7 @@
           </a:bodyPr>
           <a:lstStyle/>
           <a:p>
-            <a:pPr marL="0" indent="0" algn="l">
+            <a:pPr algn="l" indent="0" marL="0">
               <a:lnSpc>
                 <a:spcPts val="1680"/>
               </a:lnSpc>
@@ -6714,7 +7635,7 @@
           </a:bodyPr>
           <a:lstStyle/>
           <a:p>
-            <a:pPr marL="0" indent="0" algn="l">
+            <a:pPr algn="l" indent="0" marL="0">
               <a:lnSpc>
                 <a:spcPts val="1725"/>
               </a:lnSpc>
@@ -6785,7 +7706,7 @@
           </a:bodyPr>
           <a:lstStyle/>
           <a:p>
-            <a:pPr marL="0" indent="0" algn="ctr">
+            <a:pPr algn="ctr" indent="0" marL="0">
               <a:lnSpc>
                 <a:spcPts val="1470"/>
               </a:lnSpc>
@@ -6829,7 +7750,7 @@
           </a:bodyPr>
           <a:lstStyle/>
           <a:p>
-            <a:pPr marL="0" indent="0" algn="l">
+            <a:pPr algn="l" indent="0" marL="0">
               <a:lnSpc>
                 <a:spcPts val="1680"/>
               </a:lnSpc>
@@ -6900,7 +7821,7 @@
           </a:bodyPr>
           <a:lstStyle/>
           <a:p>
-            <a:pPr marL="0" indent="0" algn="ctr">
+            <a:pPr algn="ctr" indent="0" marL="0">
               <a:lnSpc>
                 <a:spcPts val="1470"/>
               </a:lnSpc>
@@ -6944,7 +7865,7 @@
           </a:bodyPr>
           <a:lstStyle/>
           <a:p>
-            <a:pPr marL="0" indent="0" algn="l">
+            <a:pPr algn="l" indent="0" marL="0">
               <a:lnSpc>
                 <a:spcPts val="1680"/>
               </a:lnSpc>
@@ -7015,7 +7936,7 @@
           </a:bodyPr>
           <a:lstStyle/>
           <a:p>
-            <a:pPr marL="0" indent="0" algn="ctr">
+            <a:pPr algn="ctr" indent="0" marL="0">
               <a:lnSpc>
                 <a:spcPts val="1470"/>
               </a:lnSpc>
@@ -7059,7 +7980,7 @@
           </a:bodyPr>
           <a:lstStyle/>
           <a:p>
-            <a:pPr marL="0" indent="0" algn="l">
+            <a:pPr algn="l" indent="0" marL="0">
               <a:lnSpc>
                 <a:spcPts val="1680"/>
               </a:lnSpc>
@@ -7130,7 +8051,7 @@
           </a:bodyPr>
           <a:lstStyle/>
           <a:p>
-            <a:pPr marL="0" indent="0" algn="ctr">
+            <a:pPr algn="ctr" indent="0" marL="0">
               <a:lnSpc>
                 <a:spcPts val="1470"/>
               </a:lnSpc>
@@ -7174,7 +8095,7 @@
           </a:bodyPr>
           <a:lstStyle/>
           <a:p>
-            <a:pPr marL="0" indent="0" algn="l">
+            <a:pPr algn="l" indent="0" marL="0">
               <a:lnSpc>
                 <a:spcPts val="1680"/>
               </a:lnSpc>
@@ -7245,7 +8166,7 @@
           </a:bodyPr>
           <a:lstStyle/>
           <a:p>
-            <a:pPr marL="0" indent="0" algn="ctr">
+            <a:pPr algn="ctr" indent="0" marL="0">
               <a:lnSpc>
                 <a:spcPts val="1470"/>
               </a:lnSpc>
@@ -7289,7 +8210,7 @@
           </a:bodyPr>
           <a:lstStyle/>
           <a:p>
-            <a:pPr marL="0" indent="0" algn="l">
+            <a:pPr algn="l" indent="0" marL="0">
               <a:lnSpc>
                 <a:spcPts val="1680"/>
               </a:lnSpc>
@@ -7360,7 +8281,7 @@
           </a:bodyPr>
           <a:lstStyle/>
           <a:p>
-            <a:pPr marL="0" indent="0" algn="ctr">
+            <a:pPr algn="ctr" indent="0" marL="0">
               <a:lnSpc>
                 <a:spcPts val="1470"/>
               </a:lnSpc>
@@ -7404,7 +8325,7 @@
           </a:bodyPr>
           <a:lstStyle/>
           <a:p>
-            <a:pPr marL="0" indent="0" algn="l">
+            <a:pPr algn="l" indent="0" marL="0">
               <a:lnSpc>
                 <a:spcPts val="1680"/>
               </a:lnSpc>
@@ -7475,7 +8396,7 @@
           </a:bodyPr>
           <a:lstStyle/>
           <a:p>
-            <a:pPr marL="0" indent="0" algn="ctr">
+            <a:pPr algn="ctr" indent="0" marL="0">
               <a:lnSpc>
                 <a:spcPts val="1470"/>
               </a:lnSpc>
@@ -7519,7 +8440,7 @@
           </a:bodyPr>
           <a:lstStyle/>
           <a:p>
-            <a:pPr marL="0" indent="0" algn="l">
+            <a:pPr algn="l" indent="0" marL="0">
               <a:lnSpc>
                 <a:spcPts val="1680"/>
               </a:lnSpc>
@@ -7585,7 +8506,7 @@
           </a:bodyPr>
           <a:lstStyle/>
           <a:p>
-            <a:pPr marL="0" indent="0" algn="ctr">
+            <a:pPr algn="ctr" indent="0" marL="0">
               <a:lnSpc>
                 <a:spcPts val="1470"/>
               </a:lnSpc>
@@ -7629,7 +8550,7 @@
           </a:bodyPr>
           <a:lstStyle/>
           <a:p>
-            <a:pPr marL="0" indent="0" algn="l">
+            <a:pPr algn="l" indent="0" marL="0">
               <a:lnSpc>
                 <a:spcPts val="1680"/>
               </a:lnSpc>
@@ -7673,7 +8594,7 @@
           </a:bodyPr>
           <a:lstStyle/>
           <a:p>
-            <a:pPr marL="0" indent="0" algn="l">
+            <a:pPr algn="l" indent="0" marL="0">
               <a:lnSpc>
                 <a:spcPts val="1680"/>
               </a:lnSpc>
@@ -7688,7 +8609,7 @@
                 <a:ea typeface="IBM Plex Sans" pitchFamily="34" charset="-122"/>
                 <a:cs typeface="IBM Plex Sans" pitchFamily="34" charset="-120"/>
               </a:rPr>
-              <a:t>2 / 14</a:t>
+              <a:t>2 / 15</a:t>
             </a:r>
             <a:endParaRPr lang="en-US" sz="1200" dirty="0"/>
           </a:p>
@@ -7710,7 +8631,6 @@
         <a:solidFill>
           <a:srgbClr val="F0EFE9"/>
         </a:solidFill>
-        <a:effectLst/>
       </p:bgPr>
     </p:bg>
     <p:spTree>
@@ -7750,14 +8670,14 @@
           </a:bodyPr>
           <a:lstStyle/>
           <a:p>
-            <a:pPr marL="0" indent="0" algn="l">
+            <a:pPr algn="l" indent="0" marL="0">
               <a:lnSpc>
                 <a:spcPts val="1680"/>
               </a:lnSpc>
               <a:buNone/>
             </a:pPr>
             <a:r>
-              <a:rPr lang="en-US" sz="1200" b="1" kern="0" spc="150" dirty="0">
+              <a:rPr lang="en-US" sz="1200" b="1" spc="150" kern="0" dirty="0">
                 <a:solidFill>
                   <a:srgbClr val="B08D57"/>
                 </a:solidFill>
@@ -7794,7 +8714,7 @@
           </a:bodyPr>
           <a:lstStyle/>
           <a:p>
-            <a:pPr marL="0" indent="0" algn="l">
+            <a:pPr algn="l" indent="0" marL="0">
               <a:lnSpc>
                 <a:spcPts val="3450"/>
               </a:lnSpc>
@@ -7883,7 +8803,7 @@
           </a:bodyPr>
           <a:lstStyle/>
           <a:p>
-            <a:pPr marL="0" indent="0" algn="l">
+            <a:pPr algn="l" indent="0" marL="0">
               <a:lnSpc>
                 <a:spcPts val="1560"/>
               </a:lnSpc>
@@ -7927,7 +8847,7 @@
           </a:bodyPr>
           <a:lstStyle/>
           <a:p>
-            <a:pPr marL="0" indent="0" algn="l">
+            <a:pPr algn="l" indent="0" marL="0">
               <a:lnSpc>
                 <a:spcPts val="1540"/>
               </a:lnSpc>
@@ -8016,7 +8936,7 @@
           </a:bodyPr>
           <a:lstStyle/>
           <a:p>
-            <a:pPr marL="0" indent="0" algn="l">
+            <a:pPr algn="l" indent="0" marL="0">
               <a:lnSpc>
                 <a:spcPts val="1560"/>
               </a:lnSpc>
@@ -8060,7 +8980,7 @@
           </a:bodyPr>
           <a:lstStyle/>
           <a:p>
-            <a:pPr marL="0" indent="0" algn="l">
+            <a:pPr algn="l" indent="0" marL="0">
               <a:lnSpc>
                 <a:spcPts val="1540"/>
               </a:lnSpc>
@@ -8149,7 +9069,7 @@
           </a:bodyPr>
           <a:lstStyle/>
           <a:p>
-            <a:pPr marL="0" indent="0" algn="l">
+            <a:pPr algn="l" indent="0" marL="0">
               <a:lnSpc>
                 <a:spcPts val="1560"/>
               </a:lnSpc>
@@ -8193,7 +9113,7 @@
           </a:bodyPr>
           <a:lstStyle/>
           <a:p>
-            <a:pPr marL="0" indent="0" algn="l">
+            <a:pPr algn="l" indent="0" marL="0">
               <a:lnSpc>
                 <a:spcPts val="1540"/>
               </a:lnSpc>
@@ -8282,7 +9202,7 @@
           </a:bodyPr>
           <a:lstStyle/>
           <a:p>
-            <a:pPr marL="0" indent="0" algn="l">
+            <a:pPr algn="l" indent="0" marL="0">
               <a:lnSpc>
                 <a:spcPts val="1560"/>
               </a:lnSpc>
@@ -8326,7 +9246,7 @@
           </a:bodyPr>
           <a:lstStyle/>
           <a:p>
-            <a:pPr marL="0" indent="0" algn="l">
+            <a:pPr algn="l" indent="0" marL="0">
               <a:lnSpc>
                 <a:spcPts val="1540"/>
               </a:lnSpc>
@@ -8415,7 +9335,7 @@
           </a:bodyPr>
           <a:lstStyle/>
           <a:p>
-            <a:pPr marL="0" indent="0" algn="l">
+            <a:pPr algn="l" indent="0" marL="0">
               <a:lnSpc>
                 <a:spcPts val="1560"/>
               </a:lnSpc>
@@ -8459,7 +9379,7 @@
           </a:bodyPr>
           <a:lstStyle/>
           <a:p>
-            <a:pPr marL="0" indent="0" algn="l">
+            <a:pPr algn="l" indent="0" marL="0">
               <a:lnSpc>
                 <a:spcPts val="1540"/>
               </a:lnSpc>
@@ -8548,7 +9468,7 @@
           </a:bodyPr>
           <a:lstStyle/>
           <a:p>
-            <a:pPr marL="0" indent="0" algn="l">
+            <a:pPr algn="l" indent="0" marL="0">
               <a:lnSpc>
                 <a:spcPts val="1560"/>
               </a:lnSpc>
@@ -8592,7 +9512,7 @@
           </a:bodyPr>
           <a:lstStyle/>
           <a:p>
-            <a:pPr marL="0" indent="0" algn="l">
+            <a:pPr algn="l" indent="0" marL="0">
               <a:lnSpc>
                 <a:spcPts val="1540"/>
               </a:lnSpc>
@@ -8636,7 +9556,7 @@
           </a:bodyPr>
           <a:lstStyle/>
           <a:p>
-            <a:pPr marL="0" indent="0" algn="l">
+            <a:pPr algn="l" indent="0" marL="0">
               <a:lnSpc>
                 <a:spcPts val="1680"/>
               </a:lnSpc>
@@ -8680,7 +9600,7 @@
           </a:bodyPr>
           <a:lstStyle/>
           <a:p>
-            <a:pPr marL="0" indent="0" algn="l">
+            <a:pPr algn="l" indent="0" marL="0">
               <a:lnSpc>
                 <a:spcPts val="1680"/>
               </a:lnSpc>
@@ -8695,7 +9615,7 @@
                 <a:ea typeface="IBM Plex Sans" pitchFamily="34" charset="-122"/>
                 <a:cs typeface="IBM Plex Sans" pitchFamily="34" charset="-120"/>
               </a:rPr>
-              <a:t>3 / 14</a:t>
+              <a:t>3 / 15</a:t>
             </a:r>
             <a:endParaRPr lang="en-US" sz="1200" dirty="0"/>
           </a:p>
@@ -8717,7 +9637,6 @@
         <a:solidFill>
           <a:srgbClr val="FBFBF8"/>
         </a:solidFill>
-        <a:effectLst/>
       </p:bgPr>
     </p:bg>
     <p:spTree>
@@ -8757,14 +9676,14 @@
           </a:bodyPr>
           <a:lstStyle/>
           <a:p>
-            <a:pPr marL="0" indent="0" algn="l">
+            <a:pPr algn="l" indent="0" marL="0">
               <a:lnSpc>
                 <a:spcPts val="1680"/>
               </a:lnSpc>
               <a:buNone/>
             </a:pPr>
             <a:r>
-              <a:rPr lang="en-US" sz="1200" b="1" kern="0" spc="150" dirty="0">
+              <a:rPr lang="en-US" sz="1200" b="1" spc="150" kern="0" dirty="0">
                 <a:solidFill>
                   <a:srgbClr val="B08D57"/>
                 </a:solidFill>
@@ -8801,7 +9720,7 @@
           </a:bodyPr>
           <a:lstStyle/>
           <a:p>
-            <a:pPr marL="0" indent="0" algn="l">
+            <a:pPr algn="l" indent="0" marL="0">
               <a:lnSpc>
                 <a:spcPts val="3450"/>
               </a:lnSpc>
@@ -8851,15 +9770,15 @@
       </p:sp>
       <p:pic>
         <p:nvPicPr>
-          <p:cNvPr id="5" name="Image 0" descr="Book"/>
+          <p:cNvPr id="5" name="Image 0" descr="Book">    </p:cNvPr>
           <p:cNvPicPr>
             <a:picLocks noChangeAspect="1"/>
           </p:cNvPicPr>
           <p:nvPr/>
         </p:nvPicPr>
         <p:blipFill>
-          <a:blip r:embed="rId3"/>
-          <a:srcRect/>
+          <a:blip r:embed="rId1"/>
+          <a:srcRect l="0" r="0" t="0" b="0"/>
           <a:stretch/>
         </p:blipFill>
         <p:spPr>
@@ -8895,7 +9814,7 @@
           </a:bodyPr>
           <a:lstStyle/>
           <a:p>
-            <a:pPr marL="0" indent="0" algn="ctr">
+            <a:pPr algn="ctr" indent="0" marL="0">
               <a:lnSpc>
                 <a:spcPts val="1540"/>
               </a:lnSpc>
@@ -8939,7 +9858,7 @@
           </a:bodyPr>
           <a:lstStyle/>
           <a:p>
-            <a:pPr marL="0" indent="0" algn="l">
+            <a:pPr algn="l" indent="0" marL="0">
               <a:lnSpc>
                 <a:spcPts val="1960"/>
               </a:lnSpc>
@@ -8989,15 +9908,15 @@
       </p:sp>
       <p:pic>
         <p:nvPicPr>
-          <p:cNvPr id="9" name="Image 1" descr="Search"/>
+          <p:cNvPr id="9" name="Image 1" descr="Search">    </p:cNvPr>
           <p:cNvPicPr>
             <a:picLocks noChangeAspect="1"/>
           </p:cNvPicPr>
           <p:nvPr/>
         </p:nvPicPr>
         <p:blipFill>
-          <a:blip r:embed="rId4"/>
-          <a:srcRect/>
+          <a:blip r:embed="rId2"/>
+          <a:srcRect l="0" r="0" t="0" b="0"/>
           <a:stretch/>
         </p:blipFill>
         <p:spPr>
@@ -9033,7 +9952,7 @@
           </a:bodyPr>
           <a:lstStyle/>
           <a:p>
-            <a:pPr marL="0" indent="0" algn="ctr">
+            <a:pPr algn="ctr" indent="0" marL="0">
               <a:lnSpc>
                 <a:spcPts val="1540"/>
               </a:lnSpc>
@@ -9077,7 +9996,7 @@
           </a:bodyPr>
           <a:lstStyle/>
           <a:p>
-            <a:pPr marL="0" indent="0" algn="ctr">
+            <a:pPr algn="ctr" indent="0" marL="0">
               <a:lnSpc>
                 <a:spcPts val="1330"/>
               </a:lnSpc>
@@ -9121,7 +10040,7 @@
           </a:bodyPr>
           <a:lstStyle/>
           <a:p>
-            <a:pPr marL="0" indent="0" algn="l">
+            <a:pPr algn="l" indent="0" marL="0">
               <a:lnSpc>
                 <a:spcPts val="1960"/>
               </a:lnSpc>
@@ -9171,15 +10090,15 @@
       </p:sp>
       <p:pic>
         <p:nvPicPr>
-          <p:cNvPr id="14" name="Image 2" descr="Code"/>
+          <p:cNvPr id="14" name="Image 2" descr="Code">    </p:cNvPr>
           <p:cNvPicPr>
             <a:picLocks noChangeAspect="1"/>
           </p:cNvPicPr>
           <p:nvPr/>
         </p:nvPicPr>
         <p:blipFill>
-          <a:blip r:embed="rId5"/>
-          <a:srcRect/>
+          <a:blip r:embed="rId3"/>
+          <a:srcRect l="0" r="0" t="0" b="0"/>
           <a:stretch/>
         </p:blipFill>
         <p:spPr>
@@ -9215,7 +10134,7 @@
           </a:bodyPr>
           <a:lstStyle/>
           <a:p>
-            <a:pPr marL="0" indent="0" algn="ctr">
+            <a:pPr algn="ctr" indent="0" marL="0">
               <a:lnSpc>
                 <a:spcPts val="1540"/>
               </a:lnSpc>
@@ -9259,7 +10178,7 @@
           </a:bodyPr>
           <a:lstStyle/>
           <a:p>
-            <a:pPr marL="0" indent="0" algn="ctr">
+            <a:pPr algn="ctr" indent="0" marL="0">
               <a:lnSpc>
                 <a:spcPts val="1330"/>
               </a:lnSpc>
@@ -9303,7 +10222,7 @@
           </a:bodyPr>
           <a:lstStyle/>
           <a:p>
-            <a:pPr marL="0" indent="0" algn="l">
+            <a:pPr algn="l" indent="0" marL="0">
               <a:lnSpc>
                 <a:spcPts val="1960"/>
               </a:lnSpc>
@@ -9353,15 +10272,15 @@
       </p:sp>
       <p:pic>
         <p:nvPicPr>
-          <p:cNvPr id="19" name="Image 3" descr="Lightning"/>
+          <p:cNvPr id="19" name="Image 3" descr="Lightning">    </p:cNvPr>
           <p:cNvPicPr>
             <a:picLocks noChangeAspect="1"/>
           </p:cNvPicPr>
           <p:nvPr/>
         </p:nvPicPr>
         <p:blipFill>
-          <a:blip r:embed="rId6"/>
-          <a:srcRect/>
+          <a:blip r:embed="rId4"/>
+          <a:srcRect l="0" r="0" t="0" b="0"/>
           <a:stretch/>
         </p:blipFill>
         <p:spPr>
@@ -9397,7 +10316,7 @@
           </a:bodyPr>
           <a:lstStyle/>
           <a:p>
-            <a:pPr marL="0" indent="0" algn="ctr">
+            <a:pPr algn="ctr" indent="0" marL="0">
               <a:lnSpc>
                 <a:spcPts val="1540"/>
               </a:lnSpc>
@@ -9441,7 +10360,7 @@
           </a:bodyPr>
           <a:lstStyle/>
           <a:p>
-            <a:pPr marL="0" indent="0" algn="ctr">
+            <a:pPr algn="ctr" indent="0" marL="0">
               <a:lnSpc>
                 <a:spcPts val="1330"/>
               </a:lnSpc>
@@ -9485,7 +10404,7 @@
           </a:bodyPr>
           <a:lstStyle/>
           <a:p>
-            <a:pPr marL="0" indent="0" algn="l">
+            <a:pPr algn="l" indent="0" marL="0">
               <a:lnSpc>
                 <a:spcPts val="1960"/>
               </a:lnSpc>
@@ -9530,15 +10449,15 @@
       </p:sp>
       <p:pic>
         <p:nvPicPr>
-          <p:cNvPr id="24" name="Image 4" descr="Database"/>
+          <p:cNvPr id="24" name="Image 4" descr="Database">    </p:cNvPr>
           <p:cNvPicPr>
             <a:picLocks noChangeAspect="1"/>
           </p:cNvPicPr>
           <p:nvPr/>
         </p:nvPicPr>
         <p:blipFill>
-          <a:blip r:embed="rId7"/>
-          <a:srcRect/>
+          <a:blip r:embed="rId5"/>
+          <a:srcRect l="0" r="0" t="0" b="0"/>
           <a:stretch/>
         </p:blipFill>
         <p:spPr>
@@ -9574,7 +10493,7 @@
           </a:bodyPr>
           <a:lstStyle/>
           <a:p>
-            <a:pPr marL="0" indent="0" algn="ctr">
+            <a:pPr algn="ctr" indent="0" marL="0">
               <a:lnSpc>
                 <a:spcPts val="1540"/>
               </a:lnSpc>
@@ -9640,7 +10559,7 @@
           </a:bodyPr>
           <a:lstStyle/>
           <a:p>
-            <a:pPr marL="0" indent="0" algn="l">
+            <a:pPr algn="l" indent="0" marL="0">
               <a:lnSpc>
                 <a:spcPts val="4480"/>
               </a:lnSpc>
@@ -9684,7 +10603,7 @@
           </a:bodyPr>
           <a:lstStyle/>
           <a:p>
-            <a:pPr marL="0" indent="0" algn="ctr">
+            <a:pPr algn="ctr" indent="0" marL="0">
               <a:lnSpc>
                 <a:spcPts val="1540"/>
               </a:lnSpc>
@@ -9750,7 +10669,7 @@
           </a:bodyPr>
           <a:lstStyle/>
           <a:p>
-            <a:pPr marL="0" indent="0" algn="l">
+            <a:pPr algn="l" indent="0" marL="0">
               <a:lnSpc>
                 <a:spcPts val="4480"/>
               </a:lnSpc>
@@ -9794,7 +10713,7 @@
           </a:bodyPr>
           <a:lstStyle/>
           <a:p>
-            <a:pPr marL="0" indent="0" algn="ctr">
+            <a:pPr algn="ctr" indent="0" marL="0">
               <a:lnSpc>
                 <a:spcPts val="1540"/>
               </a:lnSpc>
@@ -9860,7 +10779,7 @@
           </a:bodyPr>
           <a:lstStyle/>
           <a:p>
-            <a:pPr marL="0" indent="0" algn="l">
+            <a:pPr algn="l" indent="0" marL="0">
               <a:lnSpc>
                 <a:spcPts val="4480"/>
               </a:lnSpc>
@@ -9904,7 +10823,7 @@
           </a:bodyPr>
           <a:lstStyle/>
           <a:p>
-            <a:pPr marL="0" indent="0" algn="ctr">
+            <a:pPr algn="ctr" indent="0" marL="0">
               <a:lnSpc>
                 <a:spcPts val="1540"/>
               </a:lnSpc>
@@ -9970,7 +10889,7 @@
           </a:bodyPr>
           <a:lstStyle/>
           <a:p>
-            <a:pPr marL="0" indent="0" algn="l">
+            <a:pPr algn="l" indent="0" marL="0">
               <a:lnSpc>
                 <a:spcPts val="4480"/>
               </a:lnSpc>
@@ -10014,7 +10933,7 @@
           </a:bodyPr>
           <a:lstStyle/>
           <a:p>
-            <a:pPr marL="0" indent="0" algn="ctr">
+            <a:pPr algn="ctr" indent="0" marL="0">
               <a:lnSpc>
                 <a:spcPts val="1540"/>
               </a:lnSpc>
@@ -10058,7 +10977,7 @@
           </a:bodyPr>
           <a:lstStyle/>
           <a:p>
-            <a:pPr marL="0" indent="0" algn="l">
+            <a:pPr algn="l" indent="0" marL="0">
               <a:lnSpc>
                 <a:spcPts val="1680"/>
               </a:lnSpc>
@@ -10102,7 +11021,7 @@
           </a:bodyPr>
           <a:lstStyle/>
           <a:p>
-            <a:pPr marL="0" indent="0" algn="l">
+            <a:pPr algn="l" indent="0" marL="0">
               <a:lnSpc>
                 <a:spcPts val="1680"/>
               </a:lnSpc>
@@ -10117,7 +11036,7 @@
                 <a:ea typeface="IBM Plex Sans" pitchFamily="34" charset="-122"/>
                 <a:cs typeface="IBM Plex Sans" pitchFamily="34" charset="-120"/>
               </a:rPr>
-              <a:t>4 / 14</a:t>
+              <a:t>4 / 15</a:t>
             </a:r>
             <a:endParaRPr lang="en-US" sz="1200" dirty="0"/>
           </a:p>
@@ -10139,7 +11058,6 @@
         <a:solidFill>
           <a:srgbClr val="F0EFE9"/>
         </a:solidFill>
-        <a:effectLst/>
       </p:bgPr>
     </p:bg>
     <p:spTree>
@@ -10179,14 +11097,14 @@
           </a:bodyPr>
           <a:lstStyle/>
           <a:p>
-            <a:pPr marL="0" indent="0" algn="l">
+            <a:pPr algn="l" indent="0" marL="0">
               <a:lnSpc>
                 <a:spcPts val="1680"/>
               </a:lnSpc>
               <a:buNone/>
             </a:pPr>
             <a:r>
-              <a:rPr lang="en-US" sz="1200" b="1" kern="0" spc="150" dirty="0">
+              <a:rPr lang="en-US" sz="1200" b="1" spc="150" kern="0" dirty="0">
                 <a:solidFill>
                   <a:srgbClr val="B08D57"/>
                 </a:solidFill>
@@ -10223,7 +11141,7 @@
           </a:bodyPr>
           <a:lstStyle/>
           <a:p>
-            <a:pPr marL="0" indent="0" algn="l">
+            <a:pPr algn="l" indent="0" marL="0">
               <a:lnSpc>
                 <a:spcPts val="3450"/>
               </a:lnSpc>
@@ -10289,7 +11207,7 @@
           </a:bodyPr>
           <a:lstStyle/>
           <a:p>
-            <a:pPr marL="0" indent="0" algn="l">
+            <a:pPr algn="l" indent="0" marL="0">
               <a:lnSpc>
                 <a:spcPts val="1470"/>
               </a:lnSpc>
@@ -10333,7 +11251,7 @@
           </a:bodyPr>
           <a:lstStyle/>
           <a:p>
-            <a:pPr marL="0" indent="0" algn="l">
+            <a:pPr algn="l" indent="0" marL="0">
               <a:lnSpc>
                 <a:spcPts val="1400"/>
               </a:lnSpc>
@@ -10399,7 +11317,7 @@
           </a:bodyPr>
           <a:lstStyle/>
           <a:p>
-            <a:pPr marL="0" indent="0" algn="l">
+            <a:pPr algn="l" indent="0" marL="0">
               <a:lnSpc>
                 <a:spcPts val="1470"/>
               </a:lnSpc>
@@ -10443,7 +11361,7 @@
           </a:bodyPr>
           <a:lstStyle/>
           <a:p>
-            <a:pPr marL="0" indent="0" algn="l">
+            <a:pPr algn="l" indent="0" marL="0">
               <a:lnSpc>
                 <a:spcPts val="1400"/>
               </a:lnSpc>
@@ -10509,7 +11427,7 @@
           </a:bodyPr>
           <a:lstStyle/>
           <a:p>
-            <a:pPr marL="0" indent="0" algn="l">
+            <a:pPr algn="l" indent="0" marL="0">
               <a:lnSpc>
                 <a:spcPts val="1470"/>
               </a:lnSpc>
@@ -10553,7 +11471,7 @@
           </a:bodyPr>
           <a:lstStyle/>
           <a:p>
-            <a:pPr marL="0" indent="0" algn="l">
+            <a:pPr algn="l" indent="0" marL="0">
               <a:lnSpc>
                 <a:spcPts val="1400"/>
               </a:lnSpc>
@@ -10619,7 +11537,7 @@
           </a:bodyPr>
           <a:lstStyle/>
           <a:p>
-            <a:pPr marL="0" indent="0" algn="l">
+            <a:pPr algn="l" indent="0" marL="0">
               <a:lnSpc>
                 <a:spcPts val="1470"/>
               </a:lnSpc>
@@ -10663,7 +11581,7 @@
           </a:bodyPr>
           <a:lstStyle/>
           <a:p>
-            <a:pPr marL="0" indent="0" algn="l">
+            <a:pPr algn="l" indent="0" marL="0">
               <a:lnSpc>
                 <a:spcPts val="1400"/>
               </a:lnSpc>
@@ -10729,7 +11647,7 @@
           </a:bodyPr>
           <a:lstStyle/>
           <a:p>
-            <a:pPr marL="0" indent="0" algn="l">
+            <a:pPr algn="l" indent="0" marL="0">
               <a:lnSpc>
                 <a:spcPts val="1470"/>
               </a:lnSpc>
@@ -10773,7 +11691,7 @@
           </a:bodyPr>
           <a:lstStyle/>
           <a:p>
-            <a:pPr marL="0" indent="0" algn="l">
+            <a:pPr algn="l" indent="0" marL="0">
               <a:lnSpc>
                 <a:spcPts val="1400"/>
               </a:lnSpc>
@@ -10839,7 +11757,7 @@
           </a:bodyPr>
           <a:lstStyle/>
           <a:p>
-            <a:pPr marL="0" indent="0" algn="l">
+            <a:pPr algn="l" indent="0" marL="0">
               <a:lnSpc>
                 <a:spcPts val="1680"/>
               </a:lnSpc>
@@ -10883,7 +11801,7 @@
           </a:bodyPr>
           <a:lstStyle/>
           <a:p>
-            <a:pPr marL="0" indent="0" algn="l">
+            <a:pPr algn="l" indent="0" marL="0">
               <a:lnSpc>
                 <a:spcPts val="1650"/>
               </a:lnSpc>
@@ -10949,7 +11867,7 @@
           </a:bodyPr>
           <a:lstStyle/>
           <a:p>
-            <a:pPr marL="0" indent="0" algn="l">
+            <a:pPr algn="l" indent="0" marL="0">
               <a:lnSpc>
                 <a:spcPts val="1540"/>
               </a:lnSpc>
@@ -10993,7 +11911,7 @@
           </a:bodyPr>
           <a:lstStyle/>
           <a:p>
-            <a:pPr marL="0" indent="0" algn="l">
+            <a:pPr algn="l" indent="0" marL="0">
               <a:lnSpc>
                 <a:spcPts val="1540"/>
               </a:lnSpc>
@@ -11037,7 +11955,7 @@
           </a:bodyPr>
           <a:lstStyle/>
           <a:p>
-            <a:pPr marL="0" indent="0" algn="l">
+            <a:pPr algn="l" indent="0" marL="0">
               <a:lnSpc>
                 <a:spcPts val="1540"/>
               </a:lnSpc>
@@ -11081,7 +11999,7 @@
           </a:bodyPr>
           <a:lstStyle/>
           <a:p>
-            <a:pPr marL="0" indent="0" algn="l">
+            <a:pPr algn="l" indent="0" marL="0">
               <a:lnSpc>
                 <a:spcPts val="1680"/>
               </a:lnSpc>
@@ -11125,7 +12043,7 @@
           </a:bodyPr>
           <a:lstStyle/>
           <a:p>
-            <a:pPr marL="0" indent="0" algn="l">
+            <a:pPr algn="l" indent="0" marL="0">
               <a:lnSpc>
                 <a:spcPts val="1680"/>
               </a:lnSpc>
@@ -11140,7 +12058,7 @@
                 <a:ea typeface="IBM Plex Sans" pitchFamily="34" charset="-122"/>
                 <a:cs typeface="IBM Plex Sans" pitchFamily="34" charset="-120"/>
               </a:rPr>
-              <a:t>5 / 14</a:t>
+              <a:t>5 / 15</a:t>
             </a:r>
             <a:endParaRPr lang="en-US" sz="1200" dirty="0"/>
           </a:p>
@@ -11162,7 +12080,6 @@
         <a:solidFill>
           <a:srgbClr val="FBFBF8"/>
         </a:solidFill>
-        <a:effectLst/>
       </p:bgPr>
     </p:bg>
     <p:spTree>
@@ -11202,14 +12119,14 @@
           </a:bodyPr>
           <a:lstStyle/>
           <a:p>
-            <a:pPr marL="0" indent="0" algn="l">
+            <a:pPr algn="l" indent="0" marL="0">
               <a:lnSpc>
                 <a:spcPts val="1680"/>
               </a:lnSpc>
               <a:buNone/>
             </a:pPr>
             <a:r>
-              <a:rPr lang="en-US" sz="1200" b="1" kern="0" spc="150" dirty="0">
+              <a:rPr lang="en-US" sz="1200" b="1" spc="150" kern="0" dirty="0">
                 <a:solidFill>
                   <a:srgbClr val="B08D57"/>
                 </a:solidFill>
@@ -11246,7 +12163,7 @@
           </a:bodyPr>
           <a:lstStyle/>
           <a:p>
-            <a:pPr marL="0" indent="0" algn="l">
+            <a:pPr algn="l" indent="0" marL="0">
               <a:lnSpc>
                 <a:spcPts val="3450"/>
               </a:lnSpc>
@@ -11317,7 +12234,7 @@
           </a:bodyPr>
           <a:lstStyle/>
           <a:p>
-            <a:pPr marL="0" indent="0" algn="l">
+            <a:pPr algn="l" indent="0" marL="0">
               <a:lnSpc>
                 <a:spcPts val="1610"/>
               </a:lnSpc>
@@ -11361,7 +12278,7 @@
           </a:bodyPr>
           <a:lstStyle/>
           <a:p>
-            <a:pPr marL="0" indent="0" algn="l">
+            <a:pPr algn="l" indent="0" marL="0">
               <a:lnSpc>
                 <a:spcPts val="1705"/>
               </a:lnSpc>
@@ -11427,7 +12344,7 @@
           </a:bodyPr>
           <a:lstStyle/>
           <a:p>
-            <a:pPr marL="0" indent="0" algn="l">
+            <a:pPr algn="l" indent="0" marL="0">
               <a:lnSpc>
                 <a:spcPts val="3920"/>
               </a:lnSpc>
@@ -11471,7 +12388,7 @@
           </a:bodyPr>
           <a:lstStyle/>
           <a:p>
-            <a:pPr marL="0" indent="0" algn="ctr">
+            <a:pPr algn="ctr" indent="0" marL="0">
               <a:lnSpc>
                 <a:spcPts val="1470"/>
               </a:lnSpc>
@@ -11537,7 +12454,7 @@
           </a:bodyPr>
           <a:lstStyle/>
           <a:p>
-            <a:pPr marL="0" indent="0" algn="l">
+            <a:pPr algn="l" indent="0" marL="0">
               <a:lnSpc>
                 <a:spcPts val="1320"/>
               </a:lnSpc>
@@ -11581,7 +12498,7 @@
           </a:bodyPr>
           <a:lstStyle/>
           <a:p>
-            <a:pPr marL="0" indent="0" algn="l">
+            <a:pPr algn="l" indent="0" marL="0">
               <a:lnSpc>
                 <a:spcPts val="1400"/>
               </a:lnSpc>
@@ -11625,7 +12542,7 @@
           </a:bodyPr>
           <a:lstStyle/>
           <a:p>
-            <a:pPr marL="0" indent="0" algn="l">
+            <a:pPr algn="l" indent="0" marL="0">
               <a:lnSpc>
                 <a:spcPts val="1400"/>
               </a:lnSpc>
@@ -11669,7 +12586,7 @@
           </a:bodyPr>
           <a:lstStyle/>
           <a:p>
-            <a:pPr marL="0" indent="0" algn="l">
+            <a:pPr algn="l" indent="0" marL="0">
               <a:lnSpc>
                 <a:spcPts val="1400"/>
               </a:lnSpc>
@@ -11713,7 +12630,7 @@
           </a:bodyPr>
           <a:lstStyle/>
           <a:p>
-            <a:pPr marL="0" indent="0" algn="l">
+            <a:pPr algn="l" indent="0" marL="0">
               <a:lnSpc>
                 <a:spcPts val="1680"/>
               </a:lnSpc>
@@ -11757,7 +12674,7 @@
           </a:bodyPr>
           <a:lstStyle/>
           <a:p>
-            <a:pPr marL="0" indent="0" algn="l">
+            <a:pPr algn="l" indent="0" marL="0">
               <a:lnSpc>
                 <a:spcPts val="1680"/>
               </a:lnSpc>
@@ -11772,7 +12689,7 @@
                 <a:ea typeface="IBM Plex Sans" pitchFamily="34" charset="-122"/>
                 <a:cs typeface="IBM Plex Sans" pitchFamily="34" charset="-120"/>
               </a:rPr>
-              <a:t>6 / 14</a:t>
+              <a:t>6 / 15</a:t>
             </a:r>
             <a:endParaRPr lang="en-US" sz="1200" dirty="0"/>
           </a:p>
@@ -11794,7 +12711,6 @@
         <a:solidFill>
           <a:srgbClr val="1A2333"/>
         </a:solidFill>
-        <a:effectLst/>
       </p:bgPr>
     </p:bg>
     <p:spTree>
@@ -11834,14 +12750,14 @@
           </a:bodyPr>
           <a:lstStyle/>
           <a:p>
-            <a:pPr marL="0" indent="0" algn="l">
+            <a:pPr algn="l" indent="0" marL="0">
               <a:lnSpc>
                 <a:spcPts val="1680"/>
               </a:lnSpc>
               <a:buNone/>
             </a:pPr>
             <a:r>
-              <a:rPr lang="en-US" sz="1200" b="1" kern="0" spc="150" dirty="0">
+              <a:rPr lang="en-US" sz="1200" b="1" spc="150" kern="0" dirty="0">
                 <a:solidFill>
                   <a:srgbClr val="C9A86A"/>
                 </a:solidFill>
@@ -11878,7 +12794,7 @@
           </a:bodyPr>
           <a:lstStyle/>
           <a:p>
-            <a:pPr marL="0" indent="0" algn="l">
+            <a:pPr algn="l" indent="0" marL="0">
               <a:lnSpc>
                 <a:spcPts val="3450"/>
               </a:lnSpc>
@@ -11923,15 +12839,15 @@
       </p:sp>
       <p:pic>
         <p:nvPicPr>
-          <p:cNvPr id="5" name="Image 0" descr="Lock"/>
+          <p:cNvPr id="5" name="Image 0" descr="Lock">    </p:cNvPr>
           <p:cNvPicPr>
             <a:picLocks noChangeAspect="1"/>
           </p:cNvPicPr>
           <p:nvPr/>
         </p:nvPicPr>
         <p:blipFill>
-          <a:blip r:embed="rId3"/>
-          <a:srcRect/>
+          <a:blip r:embed="rId1"/>
+          <a:srcRect l="0" r="0" t="0" b="0"/>
           <a:stretch/>
         </p:blipFill>
         <p:spPr>
@@ -11967,7 +12883,7 @@
           </a:bodyPr>
           <a:lstStyle/>
           <a:p>
-            <a:pPr marL="0" indent="0" algn="l">
+            <a:pPr algn="l" indent="0" marL="0">
               <a:lnSpc>
                 <a:spcPts val="1560"/>
               </a:lnSpc>
@@ -12011,7 +12927,7 @@
           </a:bodyPr>
           <a:lstStyle/>
           <a:p>
-            <a:pPr marL="0" indent="0" algn="l">
+            <a:pPr algn="l" indent="0" marL="0">
               <a:lnSpc>
                 <a:spcPts val="1650"/>
               </a:lnSpc>
@@ -12056,15 +12972,15 @@
       </p:sp>
       <p:pic>
         <p:nvPicPr>
-          <p:cNvPr id="9" name="Image 1" descr="Users"/>
+          <p:cNvPr id="9" name="Image 1" descr="Users">    </p:cNvPr>
           <p:cNvPicPr>
             <a:picLocks noChangeAspect="1"/>
           </p:cNvPicPr>
           <p:nvPr/>
         </p:nvPicPr>
         <p:blipFill>
-          <a:blip r:embed="rId4"/>
-          <a:srcRect/>
+          <a:blip r:embed="rId2"/>
+          <a:srcRect l="0" r="0" t="0" b="0"/>
           <a:stretch/>
         </p:blipFill>
         <p:spPr>
@@ -12100,7 +13016,7 @@
           </a:bodyPr>
           <a:lstStyle/>
           <a:p>
-            <a:pPr marL="0" indent="0" algn="l">
+            <a:pPr algn="l" indent="0" marL="0">
               <a:lnSpc>
                 <a:spcPts val="1560"/>
               </a:lnSpc>
@@ -12144,7 +13060,7 @@
           </a:bodyPr>
           <a:lstStyle/>
           <a:p>
-            <a:pPr marL="0" indent="0" algn="l">
+            <a:pPr algn="l" indent="0" marL="0">
               <a:lnSpc>
                 <a:spcPts val="1650"/>
               </a:lnSpc>
@@ -12189,15 +13105,15 @@
       </p:sp>
       <p:pic>
         <p:nvPicPr>
-          <p:cNvPr id="13" name="Image 2" descr="Key"/>
+          <p:cNvPr id="13" name="Image 2" descr="Key">    </p:cNvPr>
           <p:cNvPicPr>
             <a:picLocks noChangeAspect="1"/>
           </p:cNvPicPr>
           <p:nvPr/>
         </p:nvPicPr>
         <p:blipFill>
-          <a:blip r:embed="rId5"/>
-          <a:srcRect/>
+          <a:blip r:embed="rId3"/>
+          <a:srcRect l="0" r="0" t="0" b="0"/>
           <a:stretch/>
         </p:blipFill>
         <p:spPr>
@@ -12233,7 +13149,7 @@
           </a:bodyPr>
           <a:lstStyle/>
           <a:p>
-            <a:pPr marL="0" indent="0" algn="l">
+            <a:pPr algn="l" indent="0" marL="0">
               <a:lnSpc>
                 <a:spcPts val="1560"/>
               </a:lnSpc>
@@ -12277,7 +13193,7 @@
           </a:bodyPr>
           <a:lstStyle/>
           <a:p>
-            <a:pPr marL="0" indent="0" algn="l">
+            <a:pPr algn="l" indent="0" marL="0">
               <a:lnSpc>
                 <a:spcPts val="1650"/>
               </a:lnSpc>
@@ -12321,7 +13237,7 @@
           </a:bodyPr>
           <a:lstStyle/>
           <a:p>
-            <a:pPr marL="0" indent="0" algn="l">
+            <a:pPr algn="l" indent="0" marL="0">
               <a:lnSpc>
                 <a:spcPts val="1680"/>
               </a:lnSpc>
@@ -12365,7 +13281,7 @@
           </a:bodyPr>
           <a:lstStyle/>
           <a:p>
-            <a:pPr marL="0" indent="0" algn="l">
+            <a:pPr algn="l" indent="0" marL="0">
               <a:lnSpc>
                 <a:spcPts val="1680"/>
               </a:lnSpc>
@@ -12380,7 +13296,7 @@
                 <a:ea typeface="IBM Plex Sans" pitchFamily="34" charset="-122"/>
                 <a:cs typeface="IBM Plex Sans" pitchFamily="34" charset="-120"/>
               </a:rPr>
-              <a:t>7 / 14</a:t>
+              <a:t>7 / 15</a:t>
             </a:r>
             <a:endParaRPr lang="en-US" sz="1200" dirty="0"/>
           </a:p>
@@ -12402,7 +13318,6 @@
         <a:solidFill>
           <a:srgbClr val="FBFBF8"/>
         </a:solidFill>
-        <a:effectLst/>
       </p:bgPr>
     </p:bg>
     <p:spTree>
@@ -12442,14 +13357,14 @@
           </a:bodyPr>
           <a:lstStyle/>
           <a:p>
-            <a:pPr marL="0" indent="0" algn="l">
+            <a:pPr algn="l" indent="0" marL="0">
               <a:lnSpc>
                 <a:spcPts val="1680"/>
               </a:lnSpc>
               <a:buNone/>
             </a:pPr>
             <a:r>
-              <a:rPr lang="en-US" sz="1200" b="1" kern="0" spc="150" dirty="0">
+              <a:rPr lang="en-US" sz="1200" b="1" spc="150" kern="0" dirty="0">
                 <a:solidFill>
                   <a:srgbClr val="B08D57"/>
                 </a:solidFill>
@@ -12486,7 +13401,7 @@
           </a:bodyPr>
           <a:lstStyle/>
           <a:p>
-            <a:pPr marL="0" indent="0" algn="l">
+            <a:pPr algn="l" indent="0" marL="0">
               <a:lnSpc>
                 <a:spcPts val="3450"/>
               </a:lnSpc>
@@ -12557,7 +13472,7 @@
           </a:bodyPr>
           <a:lstStyle/>
           <a:p>
-            <a:pPr marL="0" indent="0" algn="l">
+            <a:pPr algn="l" indent="0" marL="0">
               <a:lnSpc>
                 <a:spcPts val="1560"/>
               </a:lnSpc>
@@ -12601,7 +13516,7 @@
           </a:bodyPr>
           <a:lstStyle/>
           <a:p>
-            <a:pPr marL="0" indent="0" algn="l">
+            <a:pPr algn="l" indent="0" marL="0">
               <a:lnSpc>
                 <a:spcPts val="1650"/>
               </a:lnSpc>
@@ -12645,7 +13560,7 @@
           </a:bodyPr>
           <a:lstStyle/>
           <a:p>
-            <a:pPr marL="0" indent="0" algn="l">
+            <a:pPr algn="l" indent="0" marL="0">
               <a:lnSpc>
                 <a:spcPts val="1650"/>
               </a:lnSpc>
@@ -12689,7 +13604,7 @@
           </a:bodyPr>
           <a:lstStyle/>
           <a:p>
-            <a:pPr marL="0" indent="0" algn="l">
+            <a:pPr algn="l" indent="0" marL="0">
               <a:lnSpc>
                 <a:spcPts val="1650"/>
               </a:lnSpc>
@@ -12755,7 +13670,7 @@
           </a:bodyPr>
           <a:lstStyle/>
           <a:p>
-            <a:pPr marL="0" indent="0" algn="l">
+            <a:pPr algn="l" indent="0" marL="0">
               <a:lnSpc>
                 <a:spcPts val="1760"/>
               </a:lnSpc>
@@ -12799,7 +13714,7 @@
           </a:bodyPr>
           <a:lstStyle/>
           <a:p>
-            <a:pPr marL="0" indent="0" algn="l">
+            <a:pPr algn="l" indent="0" marL="0">
               <a:lnSpc>
                 <a:spcPts val="1760"/>
               </a:lnSpc>
@@ -12865,7 +13780,7 @@
           </a:bodyPr>
           <a:lstStyle/>
           <a:p>
-            <a:pPr marL="0" indent="0" algn="l">
+            <a:pPr algn="l" indent="0" marL="0">
               <a:lnSpc>
                 <a:spcPts val="1680"/>
               </a:lnSpc>
@@ -12909,7 +13824,7 @@
           </a:bodyPr>
           <a:lstStyle/>
           <a:p>
-            <a:pPr marL="0" indent="0" algn="l">
+            <a:pPr algn="l" indent="0" marL="0">
               <a:lnSpc>
                 <a:spcPts val="1680"/>
               </a:lnSpc>
@@ -12924,7 +13839,7 @@
                 <a:ea typeface="IBM Plex Sans" pitchFamily="34" charset="-122"/>
                 <a:cs typeface="IBM Plex Sans" pitchFamily="34" charset="-120"/>
               </a:rPr>
-              <a:t>8 / 14</a:t>
+              <a:t>8 / 15</a:t>
             </a:r>
             <a:endParaRPr lang="en-US" sz="1200" dirty="0"/>
           </a:p>
@@ -12946,7 +13861,6 @@
         <a:solidFill>
           <a:srgbClr val="F0EFE9"/>
         </a:solidFill>
-        <a:effectLst/>
       </p:bgPr>
     </p:bg>
     <p:spTree>
@@ -12986,14 +13900,14 @@
           </a:bodyPr>
           <a:lstStyle/>
           <a:p>
-            <a:pPr marL="0" indent="0" algn="l">
+            <a:pPr algn="l" indent="0" marL="0">
               <a:lnSpc>
                 <a:spcPts val="1680"/>
               </a:lnSpc>
               <a:buNone/>
             </a:pPr>
             <a:r>
-              <a:rPr lang="en-US" sz="1200" b="1" kern="0" spc="150" dirty="0">
+              <a:rPr lang="en-US" sz="1200" b="1" spc="150" kern="0" dirty="0">
                 <a:solidFill>
                   <a:srgbClr val="B08D57"/>
                 </a:solidFill>
@@ -13030,7 +13944,7 @@
           </a:bodyPr>
           <a:lstStyle/>
           <a:p>
-            <a:pPr marL="0" indent="0" algn="l">
+            <a:pPr algn="l" indent="0" marL="0">
               <a:lnSpc>
                 <a:spcPts val="3450"/>
               </a:lnSpc>
@@ -13096,7 +14010,7 @@
           </a:bodyPr>
           <a:lstStyle/>
           <a:p>
-            <a:pPr marL="0" indent="0" algn="ctr">
+            <a:pPr algn="ctr" indent="0" marL="0">
               <a:lnSpc>
                 <a:spcPts val="1680"/>
               </a:lnSpc>
@@ -13162,7 +14076,7 @@
           </a:bodyPr>
           <a:lstStyle/>
           <a:p>
-            <a:pPr marL="0" indent="0" algn="ctr">
+            <a:pPr algn="ctr" indent="0" marL="0">
               <a:lnSpc>
                 <a:spcPts val="1680"/>
               </a:lnSpc>
@@ -13228,7 +14142,7 @@
           </a:bodyPr>
           <a:lstStyle/>
           <a:p>
-            <a:pPr marL="0" indent="0" algn="ctr">
+            <a:pPr algn="ctr" indent="0" marL="0">
               <a:lnSpc>
                 <a:spcPts val="1680"/>
               </a:lnSpc>
@@ -13294,7 +14208,7 @@
           </a:bodyPr>
           <a:lstStyle/>
           <a:p>
-            <a:pPr marL="0" indent="0" algn="ctr">
+            <a:pPr algn="ctr" indent="0" marL="0">
               <a:lnSpc>
                 <a:spcPts val="1680"/>
               </a:lnSpc>
@@ -13360,7 +14274,7 @@
           </a:bodyPr>
           <a:lstStyle/>
           <a:p>
-            <a:pPr marL="0" indent="0" algn="l">
+            <a:pPr algn="l" indent="0" marL="0">
               <a:lnSpc>
                 <a:spcPts val="1500"/>
               </a:lnSpc>
@@ -13404,7 +14318,7 @@
           </a:bodyPr>
           <a:lstStyle/>
           <a:p>
-            <a:pPr marL="0" indent="0" algn="l">
+            <a:pPr algn="l" indent="0" marL="0">
               <a:lnSpc>
                 <a:spcPts val="1650"/>
               </a:lnSpc>
@@ -13470,7 +14384,7 @@
           </a:bodyPr>
           <a:lstStyle/>
           <a:p>
-            <a:pPr marL="0" indent="0" algn="l">
+            <a:pPr algn="l" indent="0" marL="0">
               <a:lnSpc>
                 <a:spcPts val="1500"/>
               </a:lnSpc>
@@ -13514,7 +14428,7 @@
           </a:bodyPr>
           <a:lstStyle/>
           <a:p>
-            <a:pPr marL="0" indent="0" algn="l">
+            <a:pPr algn="l" indent="0" marL="0">
               <a:lnSpc>
                 <a:spcPts val="1650"/>
               </a:lnSpc>
@@ -13558,7 +14472,7 @@
           </a:bodyPr>
           <a:lstStyle/>
           <a:p>
-            <a:pPr marL="0" indent="0" algn="l">
+            <a:pPr algn="l" indent="0" marL="0">
               <a:lnSpc>
                 <a:spcPts val="1680"/>
               </a:lnSpc>
@@ -13602,7 +14516,7 @@
           </a:bodyPr>
           <a:lstStyle/>
           <a:p>
-            <a:pPr marL="0" indent="0" algn="l">
+            <a:pPr algn="l" indent="0" marL="0">
               <a:lnSpc>
                 <a:spcPts val="1680"/>
               </a:lnSpc>
@@ -13617,7 +14531,7 @@
                 <a:ea typeface="IBM Plex Sans" pitchFamily="34" charset="-122"/>
                 <a:cs typeface="IBM Plex Sans" pitchFamily="34" charset="-120"/>
               </a:rPr>
-              <a:t>9 / 14</a:t>
+              <a:t>9 / 15</a:t>
             </a:r>
             <a:endParaRPr lang="en-US" sz="1200" dirty="0"/>
           </a:p>
@@ -13924,319 +14838,4 @@
     </a:ext>
   </a:extLst>
 </a:theme>
-</file>
-
-<file path=ppt/theme/theme2.xml><?xml version="1.0" encoding="utf-8"?>
-<a:theme xmlns:a="http://schemas.openxmlformats.org/drawingml/2006/main" name="Office Theme">
-  <a:themeElements>
-    <a:clrScheme name="Office">
-      <a:dk1>
-        <a:sysClr val="windowText" lastClr="000000"/>
-      </a:dk1>
-      <a:lt1>
-        <a:sysClr val="window" lastClr="FFFFFF"/>
-      </a:lt1>
-      <a:dk2>
-        <a:srgbClr val="0E2841"/>
-      </a:dk2>
-      <a:lt2>
-        <a:srgbClr val="E8E8E8"/>
-      </a:lt2>
-      <a:accent1>
-        <a:srgbClr val="156082"/>
-      </a:accent1>
-      <a:accent2>
-        <a:srgbClr val="E97132"/>
-      </a:accent2>
-      <a:accent3>
-        <a:srgbClr val="196B24"/>
-      </a:accent3>
-      <a:accent4>
-        <a:srgbClr val="0F9ED5"/>
-      </a:accent4>
-      <a:accent5>
-        <a:srgbClr val="A02B93"/>
-      </a:accent5>
-      <a:accent6>
-        <a:srgbClr val="4EA72E"/>
-      </a:accent6>
-      <a:hlink>
-        <a:srgbClr val="467886"/>
-      </a:hlink>
-      <a:folHlink>
-        <a:srgbClr val="96607D"/>
-      </a:folHlink>
-    </a:clrScheme>
-    <a:fontScheme name="Office">
-      <a:majorFont>
-        <a:latin typeface="Aptos Display" panose="02110004020202020204"/>
-        <a:ea typeface=""/>
-        <a:cs typeface=""/>
-        <a:font script="Jpan" typeface="游ゴシック Light"/>
-        <a:font script="Hang" typeface="맑은 고딕"/>
-        <a:font script="Hans" typeface="等线 Light"/>
-        <a:font script="Hant" typeface="新細明體"/>
-        <a:font script="Arab" typeface="Times New Roman"/>
-        <a:font script="Hebr" typeface="Times New Roman"/>
-        <a:font script="Thai" typeface="Angsana New"/>
-        <a:font script="Ethi" typeface="Nyala"/>
-        <a:font script="Beng" typeface="Vrinda"/>
-        <a:font script="Gujr" typeface="Shruti"/>
-        <a:font script="Khmr" typeface="MoolBoran"/>
-        <a:font script="Knda" typeface="Tunga"/>
-        <a:font script="Guru" typeface="Raavi"/>
-        <a:font script="Cans" typeface="Euphemia"/>
-        <a:font script="Cher" typeface="Plantagenet Cherokee"/>
-        <a:font script="Yiii" typeface="Microsoft Yi Baiti"/>
-        <a:font script="Tibt" typeface="Microsoft Himalaya"/>
-        <a:font script="Thaa" typeface="MV Boli"/>
-        <a:font script="Deva" typeface="Mangal"/>
-        <a:font script="Telu" typeface="Gautami"/>
-        <a:font script="Taml" typeface="Latha"/>
-        <a:font script="Syrc" typeface="Estrangelo Edessa"/>
-        <a:font script="Orya" typeface="Kalinga"/>
-        <a:font script="Mlym" typeface="Kartika"/>
-        <a:font script="Laoo" typeface="DokChampa"/>
-        <a:font script="Sinh" typeface="Iskoola Pota"/>
-        <a:font script="Mong" typeface="Mongolian Baiti"/>
-        <a:font script="Viet" typeface="Times New Roman"/>
-        <a:font script="Uigh" typeface="Microsoft Uighur"/>
-        <a:font script="Geor" typeface="Sylfaen"/>
-        <a:font script="Armn" typeface="Arial"/>
-        <a:font script="Bugi" typeface="Leelawadee UI"/>
-        <a:font script="Bopo" typeface="Microsoft JhengHei"/>
-        <a:font script="Java" typeface="Javanese Text"/>
-        <a:font script="Lisu" typeface="Segoe UI"/>
-        <a:font script="Mymr" typeface="Myanmar Text"/>
-        <a:font script="Nkoo" typeface="Ebrima"/>
-        <a:font script="Olck" typeface="Nirmala UI"/>
-        <a:font script="Osma" typeface="Ebrima"/>
-        <a:font script="Phag" typeface="Phagspa"/>
-        <a:font script="Syrn" typeface="Estrangelo Edessa"/>
-        <a:font script="Syrj" typeface="Estrangelo Edessa"/>
-        <a:font script="Syre" typeface="Estrangelo Edessa"/>
-        <a:font script="Sora" typeface="Nirmala UI"/>
-        <a:font script="Tale" typeface="Microsoft Tai Le"/>
-        <a:font script="Talu" typeface="Microsoft New Tai Lue"/>
-        <a:font script="Tfng" typeface="Ebrima"/>
-      </a:majorFont>
-      <a:minorFont>
-        <a:latin typeface="Aptos" panose="02110004020202020204"/>
-        <a:ea typeface=""/>
-        <a:cs typeface=""/>
-        <a:font script="Jpan" typeface="游ゴシック"/>
-        <a:font script="Hang" typeface="맑은 고딕"/>
-        <a:font script="Hans" typeface="等线"/>
-        <a:font script="Hant" typeface="新細明體"/>
-        <a:font script="Arab" typeface="Arial"/>
-        <a:font script="Hebr" typeface="Arial"/>
-        <a:font script="Thai" typeface="Cordia New"/>
-        <a:font script="Ethi" typeface="Nyala"/>
-        <a:font script="Beng" typeface="Vrinda"/>
-        <a:font script="Gujr" typeface="Shruti"/>
-        <a:font script="Khmr" typeface="DaunPenh"/>
-        <a:font script="Knda" typeface="Tunga"/>
-        <a:font script="Guru" typeface="Raavi"/>
-        <a:font script="Cans" typeface="Euphemia"/>
-        <a:font script="Cher" typeface="Plantagenet Cherokee"/>
-        <a:font script="Yiii" typeface="Microsoft Yi Baiti"/>
-        <a:font script="Tibt" typeface="Microsoft Himalaya"/>
-        <a:font script="Thaa" typeface="MV Boli"/>
-        <a:font script="Deva" typeface="Mangal"/>
-        <a:font script="Telu" typeface="Gautami"/>
-        <a:font script="Taml" typeface="Latha"/>
-        <a:font script="Syrc" typeface="Estrangelo Edessa"/>
-        <a:font script="Orya" typeface="Kalinga"/>
-        <a:font script="Mlym" typeface="Kartika"/>
-        <a:font script="Laoo" typeface="DokChampa"/>
-        <a:font script="Sinh" typeface="Iskoola Pota"/>
-        <a:font script="Mong" typeface="Mongolian Baiti"/>
-        <a:font script="Viet" typeface="Arial"/>
-        <a:font script="Uigh" typeface="Microsoft Uighur"/>
-        <a:font script="Geor" typeface="Sylfaen"/>
-        <a:font script="Armn" typeface="Arial"/>
-        <a:font script="Bugi" typeface="Leelawadee UI"/>
-        <a:font script="Bopo" typeface="Microsoft JhengHei"/>
-        <a:font script="Java" typeface="Javanese Text"/>
-        <a:font script="Lisu" typeface="Segoe UI"/>
-        <a:font script="Mymr" typeface="Myanmar Text"/>
-        <a:font script="Nkoo" typeface="Ebrima"/>
-        <a:font script="Olck" typeface="Nirmala UI"/>
-        <a:font script="Osma" typeface="Ebrima"/>
-        <a:font script="Phag" typeface="Phagspa"/>
-        <a:font script="Syrn" typeface="Estrangelo Edessa"/>
-        <a:font script="Syrj" typeface="Estrangelo Edessa"/>
-        <a:font script="Syre" typeface="Estrangelo Edessa"/>
-        <a:font script="Sora" typeface="Nirmala UI"/>
-        <a:font script="Tale" typeface="Microsoft Tai Le"/>
-        <a:font script="Talu" typeface="Microsoft New Tai Lue"/>
-        <a:font script="Tfng" typeface="Ebrima"/>
-      </a:minorFont>
-    </a:fontScheme>
-    <a:fmtScheme name="Office">
-      <a:fillStyleLst>
-        <a:solidFill>
-          <a:schemeClr val="phClr"/>
-        </a:solidFill>
-        <a:gradFill rotWithShape="1">
-          <a:gsLst>
-            <a:gs pos="0">
-              <a:schemeClr val="phClr">
-                <a:lumMod val="110000"/>
-                <a:satMod val="105000"/>
-                <a:tint val="67000"/>
-              </a:schemeClr>
-            </a:gs>
-            <a:gs pos="50000">
-              <a:schemeClr val="phClr">
-                <a:lumMod val="105000"/>
-                <a:satMod val="103000"/>
-                <a:tint val="73000"/>
-              </a:schemeClr>
-            </a:gs>
-            <a:gs pos="100000">
-              <a:schemeClr val="phClr">
-                <a:lumMod val="105000"/>
-                <a:satMod val="109000"/>
-                <a:tint val="81000"/>
-              </a:schemeClr>
-            </a:gs>
-          </a:gsLst>
-          <a:lin ang="5400000" scaled="0"/>
-        </a:gradFill>
-        <a:gradFill rotWithShape="1">
-          <a:gsLst>
-            <a:gs pos="0">
-              <a:schemeClr val="phClr">
-                <a:satMod val="103000"/>
-                <a:lumMod val="102000"/>
-                <a:tint val="94000"/>
-              </a:schemeClr>
-            </a:gs>
-            <a:gs pos="50000">
-              <a:schemeClr val="phClr">
-                <a:satMod val="110000"/>
-                <a:lumMod val="100000"/>
-                <a:shade val="100000"/>
-              </a:schemeClr>
-            </a:gs>
-            <a:gs pos="100000">
-              <a:schemeClr val="phClr">
-                <a:lumMod val="99000"/>
-                <a:satMod val="120000"/>
-                <a:shade val="78000"/>
-              </a:schemeClr>
-            </a:gs>
-          </a:gsLst>
-          <a:lin ang="5400000" scaled="0"/>
-        </a:gradFill>
-      </a:fillStyleLst>
-      <a:lnStyleLst>
-        <a:ln w="12700" cap="flat" cmpd="sng" algn="ctr">
-          <a:solidFill>
-            <a:schemeClr val="phClr"/>
-          </a:solidFill>
-          <a:prstDash val="solid"/>
-          <a:miter lim="800000"/>
-        </a:ln>
-        <a:ln w="19050" cap="flat" cmpd="sng" algn="ctr">
-          <a:solidFill>
-            <a:schemeClr val="phClr"/>
-          </a:solidFill>
-          <a:prstDash val="solid"/>
-          <a:miter lim="800000"/>
-        </a:ln>
-        <a:ln w="25400" cap="flat" cmpd="sng" algn="ctr">
-          <a:solidFill>
-            <a:schemeClr val="phClr"/>
-          </a:solidFill>
-          <a:prstDash val="solid"/>
-          <a:miter lim="800000"/>
-        </a:ln>
-      </a:lnStyleLst>
-      <a:effectStyleLst>
-        <a:effectStyle>
-          <a:effectLst/>
-        </a:effectStyle>
-        <a:effectStyle>
-          <a:effectLst/>
-        </a:effectStyle>
-        <a:effectStyle>
-          <a:effectLst>
-            <a:outerShdw blurRad="57150" dist="19050" dir="5400000" algn="ctr" rotWithShape="0">
-              <a:srgbClr val="000000">
-                <a:alpha val="63000"/>
-              </a:srgbClr>
-            </a:outerShdw>
-          </a:effectLst>
-        </a:effectStyle>
-      </a:effectStyleLst>
-      <a:bgFillStyleLst>
-        <a:solidFill>
-          <a:schemeClr val="phClr"/>
-        </a:solidFill>
-        <a:solidFill>
-          <a:schemeClr val="phClr">
-            <a:tint val="95000"/>
-            <a:satMod val="170000"/>
-          </a:schemeClr>
-        </a:solidFill>
-        <a:gradFill rotWithShape="1">
-          <a:gsLst>
-            <a:gs pos="0">
-              <a:schemeClr val="phClr">
-                <a:tint val="93000"/>
-                <a:satMod val="150000"/>
-                <a:shade val="98000"/>
-                <a:lumMod val="102000"/>
-              </a:schemeClr>
-            </a:gs>
-            <a:gs pos="50000">
-              <a:schemeClr val="phClr">
-                <a:tint val="98000"/>
-                <a:satMod val="130000"/>
-                <a:shade val="90000"/>
-                <a:lumMod val="103000"/>
-              </a:schemeClr>
-            </a:gs>
-            <a:gs pos="100000">
-              <a:schemeClr val="phClr">
-                <a:shade val="63000"/>
-                <a:satMod val="120000"/>
-              </a:schemeClr>
-            </a:gs>
-          </a:gsLst>
-          <a:lin ang="5400000" scaled="0"/>
-        </a:gradFill>
-      </a:bgFillStyleLst>
-    </a:fmtScheme>
-  </a:themeElements>
-  <a:objectDefaults>
-    <a:lnDef>
-      <a:spPr/>
-      <a:bodyPr/>
-      <a:lstStyle/>
-      <a:style>
-        <a:lnRef idx="2">
-          <a:schemeClr val="accent1"/>
-        </a:lnRef>
-        <a:fillRef idx="0">
-          <a:schemeClr val="accent1"/>
-        </a:fillRef>
-        <a:effectRef idx="1">
-          <a:schemeClr val="accent1"/>
-        </a:effectRef>
-        <a:fontRef idx="minor">
-          <a:schemeClr val="tx1"/>
-        </a:fontRef>
-      </a:style>
-    </a:lnDef>
-  </a:objectDefaults>
-  <a:extraClrSchemeLst/>
-  <a:extLst>
-    <a:ext uri="{05A4C25C-085E-4340-85A3-A5531E510DB2}">
-      <thm15:themeFamily xmlns:thm15="http://schemas.microsoft.com/office/thememl/2012/main" name="Office Theme" id="{2E142A2C-CD16-42D6-873A-C26D2A0506FA}" vid="{1BDDFF52-6CD6-40A5-AB3C-68EB2F1E4D0A}"/>
-    </a:ext>
-  </a:extLst>
-</a:theme>
 </file>
</xml_diff>